<commit_message>
docs: update RentEquip college review presentation to 10 slides with flowchart, clean typography, and zero emojis
</commit_message>
<xml_diff>
--- a/RentEquip_Presentation.pptx
+++ b/RentEquip_Presentation.pptx
@@ -11,6 +11,10 @@
     <p:sldId id="259" r:id="rId10"/>
     <p:sldId id="260" r:id="rId11"/>
     <p:sldId id="261" r:id="rId12"/>
+    <p:sldId id="262" r:id="rId13"/>
+    <p:sldId id="263" r:id="rId14"/>
+    <p:sldId id="264" r:id="rId15"/>
+    <p:sldId id="265" r:id="rId16"/>
   </p:sldIdLst>
   <p:sldSz cx="12191695" cy="6858000" type="screen4x3"/>
   <p:notesSz cx="6858000" cy="9144000"/>
@@ -3187,8 +3191,8 @@
         </p:nvSpPr>
         <p:spPr>
           <a:xfrm>
-            <a:off x="731520" y="914400"/>
-            <a:ext cx="4572000" cy="365760"/>
+            <a:off x="731520" y="731520"/>
+            <a:ext cx="5029200" cy="365760"/>
           </a:xfrm>
           <a:prstGeom prst="rect">
             <a:avLst/>
@@ -3209,7 +3213,7 @@
               </a:defRPr>
             </a:pPr>
             <a:r>
-              <a:t>COURSE PROJECT PRESENTATION</a:t>
+              <a:t>COLLEGE PROJECT PRESENTATION</a:t>
             </a:r>
           </a:p>
         </p:txBody>
@@ -3222,7 +3226,7 @@
         </p:nvSpPr>
         <p:spPr>
           <a:xfrm>
-            <a:off x="731520" y="1371600"/>
+            <a:off x="731520" y="1188720"/>
             <a:ext cx="5029200" cy="1097280"/>
           </a:xfrm>
           <a:prstGeom prst="rect">
@@ -3237,7 +3241,7 @@
           <a:lstStyle/>
           <a:p>
             <a:pPr>
-              <a:defRPr sz="5400" b="1">
+              <a:defRPr sz="5000" b="1">
                 <a:solidFill>
                   <a:srgbClr val="FFFFFF"/>
                 </a:solidFill>
@@ -3257,8 +3261,8 @@
         </p:nvSpPr>
         <p:spPr>
           <a:xfrm>
-            <a:off x="731520" y="2468880"/>
-            <a:ext cx="5029200" cy="914400"/>
+            <a:off x="731520" y="2194560"/>
+            <a:ext cx="5029200" cy="822960"/>
           </a:xfrm>
           <a:prstGeom prst="rect">
             <a:avLst/>
@@ -3272,14 +3276,14 @@
           <a:lstStyle/>
           <a:p>
             <a:pPr>
-              <a:defRPr sz="1800">
+              <a:defRPr sz="2000">
                 <a:solidFill>
                   <a:srgbClr val="D1DCD7"/>
                 </a:solidFill>
               </a:defRPr>
             </a:pPr>
             <a:r>
-              <a:t>College Campus Equipment &amp; Study Resource Rental Marketplace</a:t>
+              <a:t>Campus Equipment Rental Marketplace</a:t>
             </a:r>
           </a:p>
         </p:txBody>
@@ -3292,8 +3296,8 @@
         </p:nvSpPr>
         <p:spPr>
           <a:xfrm>
-            <a:off x="731520" y="3474720"/>
-            <a:ext cx="4114800" cy="54864"/>
+            <a:off x="731520" y="3154680"/>
+            <a:ext cx="4114800" cy="45720"/>
           </a:xfrm>
           <a:prstGeom prst="rect">
             <a:avLst/>
@@ -3335,8 +3339,8 @@
         </p:nvSpPr>
         <p:spPr>
           <a:xfrm>
-            <a:off x="731520" y="3749039"/>
-            <a:ext cx="5029200" cy="2560320"/>
+            <a:off x="731520" y="3383280"/>
+            <a:ext cx="5029200" cy="2926080"/>
           </a:xfrm>
           <a:prstGeom prst="rect">
             <a:avLst/>
@@ -3362,6 +3366,9 @@
           </a:p>
           <a:p>
             <a:pPr>
+              <a:spcBef>
+                <a:spcPts val="800"/>
+              </a:spcBef>
               <a:defRPr sz="2000" b="1">
                 <a:solidFill>
                   <a:srgbClr val="FFFFFF"/>
@@ -3374,6 +3381,9 @@
           </a:p>
           <a:p>
             <a:pPr>
+              <a:spcBef>
+                <a:spcPts val="400"/>
+              </a:spcBef>
               <a:defRPr sz="1800" b="1">
                 <a:solidFill>
                   <a:srgbClr val="F59E0B"/>
@@ -3386,6 +3396,9 @@
           </a:p>
           <a:p>
             <a:pPr>
+              <a:spcBef>
+                <a:spcPts val="400"/>
+              </a:spcBef>
               <a:defRPr sz="1400">
                 <a:solidFill>
                   <a:srgbClr val="A3B8B0"/>
@@ -3400,7 +3413,7 @@
       </p:sp>
       <p:pic>
         <p:nvPicPr>
-          <p:cNvPr id="9" name="Picture 8" descr="slide1_gear.png"/>
+          <p:cNvPr id="9" name="Picture 8" descr="slide1_campus.png"/>
           <p:cNvPicPr>
             <a:picLocks noChangeAspect="1"/>
           </p:cNvPicPr>
@@ -3414,8 +3427,420 @@
         </p:blipFill>
         <p:spPr>
           <a:xfrm>
-            <a:off x="6583680" y="914400"/>
+            <a:off x="6583680" y="822960"/>
             <a:ext cx="5029200" cy="5029200"/>
+          </a:xfrm>
+          <a:prstGeom prst="rect">
+            <a:avLst/>
+          </a:prstGeom>
+        </p:spPr>
+      </p:pic>
+    </p:spTree>
+  </p:cSld>
+  <p:clrMapOvr>
+    <a:masterClrMapping/>
+  </p:clrMapOvr>
+</p:sld>
+</file>
+
+<file path=ppt/slides/slide10.xml><?xml version="1.0" encoding="utf-8"?>
+<p:sld xmlns:a="http://schemas.openxmlformats.org/drawingml/2006/main" xmlns:p="http://schemas.openxmlformats.org/presentationml/2006/main" xmlns:r="http://schemas.openxmlformats.org/officeDocument/2006/relationships">
+  <p:cSld>
+    <p:spTree>
+      <p:nvGrpSpPr>
+        <p:cNvPr id="1" name=""/>
+        <p:cNvGrpSpPr/>
+        <p:nvPr/>
+      </p:nvGrpSpPr>
+      <p:grpSpPr/>
+      <p:sp>
+        <p:nvSpPr>
+          <p:cNvPr id="2" name="Rectangle 1"/>
+          <p:cNvSpPr/>
+          <p:nvPr/>
+        </p:nvSpPr>
+        <p:spPr>
+          <a:xfrm>
+            <a:off x="0" y="0"/>
+            <a:ext cx="12191695" cy="1051560"/>
+          </a:xfrm>
+          <a:prstGeom prst="rect">
+            <a:avLst/>
+          </a:prstGeom>
+          <a:solidFill>
+            <a:srgbClr val="1B4332"/>
+          </a:solidFill>
+          <a:ln>
+            <a:noFill/>
+          </a:ln>
+        </p:spPr>
+        <p:style>
+          <a:lnRef idx="1">
+            <a:schemeClr val="accent1"/>
+          </a:lnRef>
+          <a:fillRef idx="3">
+            <a:schemeClr val="accent1"/>
+          </a:fillRef>
+          <a:effectRef idx="2">
+            <a:schemeClr val="accent1"/>
+          </a:effectRef>
+          <a:fontRef idx="minor">
+            <a:schemeClr val="lt1"/>
+          </a:fontRef>
+        </p:style>
+        <p:txBody>
+          <a:bodyPr rtlCol="0" anchor="ctr"/>
+          <a:lstStyle/>
+          <a:p>
+            <a:pPr algn="ctr"/>
+          </a:p>
+        </p:txBody>
+      </p:sp>
+      <p:sp>
+        <p:nvSpPr>
+          <p:cNvPr id="3" name="Rectangle 2"/>
+          <p:cNvSpPr/>
+          <p:nvPr/>
+        </p:nvSpPr>
+        <p:spPr>
+          <a:xfrm>
+            <a:off x="0" y="1051560"/>
+            <a:ext cx="12191695" cy="54864"/>
+          </a:xfrm>
+          <a:prstGeom prst="rect">
+            <a:avLst/>
+          </a:prstGeom>
+          <a:solidFill>
+            <a:srgbClr val="FF6B35"/>
+          </a:solidFill>
+          <a:ln>
+            <a:noFill/>
+          </a:ln>
+        </p:spPr>
+        <p:style>
+          <a:lnRef idx="1">
+            <a:schemeClr val="accent1"/>
+          </a:lnRef>
+          <a:fillRef idx="3">
+            <a:schemeClr val="accent1"/>
+          </a:fillRef>
+          <a:effectRef idx="2">
+            <a:schemeClr val="accent1"/>
+          </a:effectRef>
+          <a:fontRef idx="minor">
+            <a:schemeClr val="lt1"/>
+          </a:fontRef>
+        </p:style>
+        <p:txBody>
+          <a:bodyPr rtlCol="0" anchor="ctr"/>
+          <a:lstStyle/>
+          <a:p>
+            <a:pPr algn="ctr"/>
+          </a:p>
+        </p:txBody>
+      </p:sp>
+      <p:sp>
+        <p:nvSpPr>
+          <p:cNvPr id="4" name="TextBox 3"/>
+          <p:cNvSpPr txBox="1"/>
+          <p:nvPr/>
+        </p:nvSpPr>
+        <p:spPr>
+          <a:xfrm>
+            <a:off x="731520" y="109728"/>
+            <a:ext cx="5486400" cy="256032"/>
+          </a:xfrm>
+          <a:prstGeom prst="rect">
+            <a:avLst/>
+          </a:prstGeom>
+          <a:noFill/>
+        </p:spPr>
+        <p:txBody>
+          <a:bodyPr wrap="none">
+            <a:spAutoFit/>
+          </a:bodyPr>
+          <a:lstStyle/>
+          <a:p>
+            <a:pPr>
+              <a:defRPr sz="1100" b="1">
+                <a:solidFill>
+                  <a:srgbClr val="F59E0B"/>
+                </a:solidFill>
+              </a:defRPr>
+            </a:pPr>
+            <a:r>
+              <a:t>PROJECT SUMMARY</a:t>
+            </a:r>
+          </a:p>
+        </p:txBody>
+      </p:sp>
+      <p:sp>
+        <p:nvSpPr>
+          <p:cNvPr id="5" name="TextBox 4"/>
+          <p:cNvSpPr txBox="1"/>
+          <p:nvPr/>
+        </p:nvSpPr>
+        <p:spPr>
+          <a:xfrm>
+            <a:off x="731520" y="365760"/>
+            <a:ext cx="8686800" cy="594360"/>
+          </a:xfrm>
+          <a:prstGeom prst="rect">
+            <a:avLst/>
+          </a:prstGeom>
+          <a:noFill/>
+        </p:spPr>
+        <p:txBody>
+          <a:bodyPr wrap="none">
+            <a:spAutoFit/>
+          </a:bodyPr>
+          <a:lstStyle/>
+          <a:p>
+            <a:pPr>
+              <a:defRPr sz="2400" b="1">
+                <a:solidFill>
+                  <a:srgbClr val="FFFFFF"/>
+                </a:solidFill>
+              </a:defRPr>
+            </a:pPr>
+            <a:r>
+              <a:t>Conclusion</a:t>
+            </a:r>
+          </a:p>
+        </p:txBody>
+      </p:sp>
+      <p:sp>
+        <p:nvSpPr>
+          <p:cNvPr id="6" name="TextBox 5"/>
+          <p:cNvSpPr txBox="1"/>
+          <p:nvPr/>
+        </p:nvSpPr>
+        <p:spPr>
+          <a:xfrm>
+            <a:off x="10241280" y="320040"/>
+            <a:ext cx="1371600" cy="457200"/>
+          </a:xfrm>
+          <a:prstGeom prst="rect">
+            <a:avLst/>
+          </a:prstGeom>
+          <a:noFill/>
+        </p:spPr>
+        <p:txBody>
+          <a:bodyPr wrap="none">
+            <a:spAutoFit/>
+          </a:bodyPr>
+          <a:lstStyle/>
+          <a:p>
+            <a:pPr algn="r">
+              <a:defRPr sz="1600" b="1">
+                <a:solidFill>
+                  <a:srgbClr val="F59E0B"/>
+                </a:solidFill>
+              </a:defRPr>
+            </a:pPr>
+            <a:r>
+              <a:t>10 / 10</a:t>
+            </a:r>
+          </a:p>
+        </p:txBody>
+      </p:sp>
+      <p:sp>
+        <p:nvSpPr>
+          <p:cNvPr id="7" name="TextBox 6"/>
+          <p:cNvSpPr txBox="1"/>
+          <p:nvPr/>
+        </p:nvSpPr>
+        <p:spPr>
+          <a:xfrm>
+            <a:off x="731520" y="1371600"/>
+            <a:ext cx="5486400" cy="4937760"/>
+          </a:xfrm>
+          <a:prstGeom prst="rect">
+            <a:avLst/>
+          </a:prstGeom>
+          <a:noFill/>
+        </p:spPr>
+        <p:txBody>
+          <a:bodyPr wrap="square">
+            <a:spAutoFit/>
+          </a:bodyPr>
+          <a:lstStyle/>
+          <a:p>
+            <a:pPr>
+              <a:defRPr sz="1900" b="1">
+                <a:solidFill>
+                  <a:srgbClr val="1B4332"/>
+                </a:solidFill>
+              </a:defRPr>
+            </a:pPr>
+            <a:r>
+              <a:t>Project Takeaways:</a:t>
+            </a:r>
+          </a:p>
+          <a:p>
+            <a:pPr>
+              <a:spcBef>
+                <a:spcPts val="1200"/>
+              </a:spcBef>
+            </a:pPr>
+            <a:r>
+              <a:rPr b="1" sz="1400">
+                <a:solidFill>
+                  <a:srgbClr val="1C2826"/>
+                </a:solidFill>
+              </a:rPr>
+              <a:t>• Campus-Focused Utility: </a:t>
+            </a:r>
+            <a:r>
+              <a:rPr sz="1300">
+                <a:solidFill>
+                  <a:srgbClr val="4B5D56"/>
+                </a:solidFill>
+              </a:rPr>
+              <a:t>RentEquip provides a practical, user-friendly rental marketplace tailored to actual student needs.</a:t>
+            </a:r>
+          </a:p>
+          <a:p>
+            <a:pPr>
+              <a:spcBef>
+                <a:spcPts val="1200"/>
+              </a:spcBef>
+            </a:pPr>
+            <a:r>
+              <a:rPr b="1" sz="1400">
+                <a:solidFill>
+                  <a:srgbClr val="1C2826"/>
+                </a:solidFill>
+              </a:rPr>
+              <a:t>• Connecting Students &amp; Clubs: </a:t>
+            </a:r>
+            <a:r>
+              <a:rPr sz="1300">
+                <a:solidFill>
+                  <a:srgbClr val="4B5D56"/>
+                </a:solidFill>
+              </a:rPr>
+              <a:t>Bridges the gap between students with idle equipment and peers who need temporary access.</a:t>
+            </a:r>
+          </a:p>
+          <a:p>
+            <a:pPr>
+              <a:spcBef>
+                <a:spcPts val="1200"/>
+              </a:spcBef>
+            </a:pPr>
+            <a:r>
+              <a:rPr b="1" sz="1400">
+                <a:solidFill>
+                  <a:srgbClr val="1C2826"/>
+                </a:solidFill>
+              </a:rPr>
+              <a:t>• Practical Web Engineering: </a:t>
+            </a:r>
+            <a:r>
+              <a:rPr sz="1300">
+                <a:solidFill>
+                  <a:srgbClr val="4B5D56"/>
+                </a:solidFill>
+              </a:rPr>
+              <a:t>Demonstrates how core HTML, CSS, and JavaScript can deliver a responsive, interactive web application deployed live on the cloud.</a:t>
+            </a:r>
+          </a:p>
+          <a:p>
+            <a:pPr>
+              <a:spcBef>
+                <a:spcPts val="1200"/>
+              </a:spcBef>
+            </a:pPr>
+            <a:r>
+              <a:rPr b="1" sz="1400">
+                <a:solidFill>
+                  <a:srgbClr val="1C2826"/>
+                </a:solidFill>
+              </a:rPr>
+              <a:t>• Sustainable Academic Sharing: </a:t>
+            </a:r>
+            <a:r>
+              <a:rPr sz="1300">
+                <a:solidFill>
+                  <a:srgbClr val="4B5D56"/>
+                </a:solidFill>
+              </a:rPr>
+              <a:t>Promotes an organized, affordable circular economy within the college campus community.</a:t>
+            </a:r>
+          </a:p>
+        </p:txBody>
+      </p:sp>
+      <p:sp>
+        <p:nvSpPr>
+          <p:cNvPr id="8" name="Rounded Rectangle 7"/>
+          <p:cNvSpPr/>
+          <p:nvPr/>
+        </p:nvSpPr>
+        <p:spPr>
+          <a:xfrm>
+            <a:off x="731520" y="5394960"/>
+            <a:ext cx="5486400" cy="822960"/>
+          </a:xfrm>
+          <a:prstGeom prst="roundRect">
+            <a:avLst/>
+          </a:prstGeom>
+          <a:solidFill>
+            <a:srgbClr val="FF6B35"/>
+          </a:solidFill>
+          <a:ln>
+            <a:noFill/>
+          </a:ln>
+        </p:spPr>
+        <p:style>
+          <a:lnRef idx="1">
+            <a:schemeClr val="accent1"/>
+          </a:lnRef>
+          <a:fillRef idx="3">
+            <a:schemeClr val="accent1"/>
+          </a:fillRef>
+          <a:effectRef idx="2">
+            <a:schemeClr val="accent1"/>
+          </a:effectRef>
+          <a:fontRef idx="minor">
+            <a:schemeClr val="lt1"/>
+          </a:fontRef>
+        </p:style>
+        <p:txBody>
+          <a:bodyPr rtlCol="0" anchor="ctr"/>
+          <a:lstStyle/>
+          <a:p>
+            <a:pPr algn="ctr">
+              <a:defRPr sz="1600" b="1">
+                <a:solidFill>
+                  <a:srgbClr val="FFFFFF"/>
+                </a:solidFill>
+              </a:defRPr>
+            </a:pPr>
+            <a:r>
+              <a:t>Rent smarter. Share better. Learn together.</a:t>
+            </a:r>
+          </a:p>
+        </p:txBody>
+      </p:sp>
+      <p:pic>
+        <p:nvPicPr>
+          <p:cNvPr id="9" name="Picture 8" descr="slide10_conclusion.png"/>
+          <p:cNvPicPr>
+            <a:picLocks noChangeAspect="1"/>
+          </p:cNvPicPr>
+          <p:nvPr/>
+        </p:nvPicPr>
+        <p:blipFill>
+          <a:blip r:embed="rId2"/>
+          <a:stretch>
+            <a:fillRect/>
+          </a:stretch>
+        </p:blipFill>
+        <p:spPr>
+          <a:xfrm>
+            <a:off x="6492240" y="1371600"/>
+            <a:ext cx="5029200" cy="4846320"/>
           </a:xfrm>
           <a:prstGeom prst="rect">
             <a:avLst/>
@@ -3449,7 +3874,7 @@
         <p:spPr>
           <a:xfrm>
             <a:off x="0" y="0"/>
-            <a:ext cx="12191695" cy="1097280"/>
+            <a:ext cx="12191695" cy="1051560"/>
           </a:xfrm>
           <a:prstGeom prst="rect">
             <a:avLst/>
@@ -3491,8 +3916,8 @@
         </p:nvSpPr>
         <p:spPr>
           <a:xfrm>
-            <a:off x="0" y="1097280"/>
-            <a:ext cx="12191695" cy="73152"/>
+            <a:off x="0" y="1051560"/>
+            <a:ext cx="12191695" cy="54864"/>
           </a:xfrm>
           <a:prstGeom prst="rect">
             <a:avLst/>
@@ -3534,8 +3959,113 @@
         </p:nvSpPr>
         <p:spPr>
           <a:xfrm>
-            <a:off x="731520" y="164592"/>
-            <a:ext cx="4572000" cy="274320"/>
+            <a:off x="731520" y="109728"/>
+            <a:ext cx="5486400" cy="256032"/>
+          </a:xfrm>
+          <a:prstGeom prst="rect">
+            <a:avLst/>
+          </a:prstGeom>
+          <a:noFill/>
+        </p:spPr>
+        <p:txBody>
+          <a:bodyPr wrap="none">
+            <a:spAutoFit/>
+          </a:bodyPr>
+          <a:lstStyle/>
+          <a:p>
+            <a:pPr>
+              <a:defRPr sz="1100" b="1">
+                <a:solidFill>
+                  <a:srgbClr val="F59E0B"/>
+                </a:solidFill>
+              </a:defRPr>
+            </a:pPr>
+            <a:r>
+              <a:t>THE CAMPUS CHALLENGE</a:t>
+            </a:r>
+          </a:p>
+        </p:txBody>
+      </p:sp>
+      <p:sp>
+        <p:nvSpPr>
+          <p:cNvPr id="5" name="TextBox 4"/>
+          <p:cNvSpPr txBox="1"/>
+          <p:nvPr/>
+        </p:nvSpPr>
+        <p:spPr>
+          <a:xfrm>
+            <a:off x="731520" y="365760"/>
+            <a:ext cx="8686800" cy="594360"/>
+          </a:xfrm>
+          <a:prstGeom prst="rect">
+            <a:avLst/>
+          </a:prstGeom>
+          <a:noFill/>
+        </p:spPr>
+        <p:txBody>
+          <a:bodyPr wrap="none">
+            <a:spAutoFit/>
+          </a:bodyPr>
+          <a:lstStyle/>
+          <a:p>
+            <a:pPr>
+              <a:defRPr sz="2400" b="1">
+                <a:solidFill>
+                  <a:srgbClr val="FFFFFF"/>
+                </a:solidFill>
+              </a:defRPr>
+            </a:pPr>
+            <a:r>
+              <a:t>Problem Statement</a:t>
+            </a:r>
+          </a:p>
+        </p:txBody>
+      </p:sp>
+      <p:sp>
+        <p:nvSpPr>
+          <p:cNvPr id="6" name="TextBox 5"/>
+          <p:cNvSpPr txBox="1"/>
+          <p:nvPr/>
+        </p:nvSpPr>
+        <p:spPr>
+          <a:xfrm>
+            <a:off x="10241280" y="320040"/>
+            <a:ext cx="1371600" cy="457200"/>
+          </a:xfrm>
+          <a:prstGeom prst="rect">
+            <a:avLst/>
+          </a:prstGeom>
+          <a:noFill/>
+        </p:spPr>
+        <p:txBody>
+          <a:bodyPr wrap="none">
+            <a:spAutoFit/>
+          </a:bodyPr>
+          <a:lstStyle/>
+          <a:p>
+            <a:pPr algn="r">
+              <a:defRPr sz="1600" b="1">
+                <a:solidFill>
+                  <a:srgbClr val="F59E0B"/>
+                </a:solidFill>
+              </a:defRPr>
+            </a:pPr>
+            <a:r>
+              <a:t>02 / 10</a:t>
+            </a:r>
+          </a:p>
+        </p:txBody>
+      </p:sp>
+      <p:sp>
+        <p:nvSpPr>
+          <p:cNvPr id="7" name="TextBox 6"/>
+          <p:cNvSpPr txBox="1"/>
+          <p:nvPr/>
+        </p:nvSpPr>
+        <p:spPr>
+          <a:xfrm>
+            <a:off x="731520" y="1371600"/>
+            <a:ext cx="5486400" cy="4937760"/>
           </a:xfrm>
           <a:prstGeom prst="rect">
             <a:avLst/>
@@ -3549,90 +4079,20 @@
           <a:lstStyle/>
           <a:p>
             <a:pPr>
-              <a:defRPr sz="1100" b="1">
-                <a:solidFill>
-                  <a:srgbClr val="F59E0B"/>
+              <a:defRPr sz="1900" b="1">
+                <a:solidFill>
+                  <a:srgbClr val="1B4332"/>
                 </a:solidFill>
               </a:defRPr>
             </a:pPr>
             <a:r>
-              <a:t>🎓 THE CAMPUS CHALLENGE</a:t>
-            </a:r>
-          </a:p>
-        </p:txBody>
-      </p:sp>
-      <p:sp>
-        <p:nvSpPr>
-          <p:cNvPr id="5" name="TextBox 4"/>
-          <p:cNvSpPr txBox="1"/>
-          <p:nvPr/>
-        </p:nvSpPr>
-        <p:spPr>
-          <a:xfrm>
-            <a:off x="731520" y="411480"/>
-            <a:ext cx="10058400" cy="548640"/>
-          </a:xfrm>
-          <a:prstGeom prst="rect">
-            <a:avLst/>
-          </a:prstGeom>
-          <a:noFill/>
-        </p:spPr>
-        <p:txBody>
-          <a:bodyPr wrap="square">
-            <a:spAutoFit/>
-          </a:bodyPr>
-          <a:lstStyle/>
-          <a:p>
-            <a:pPr>
-              <a:defRPr sz="2600" b="1">
-                <a:solidFill>
-                  <a:srgbClr val="FFFFFF"/>
-                </a:solidFill>
-              </a:defRPr>
-            </a:pPr>
-            <a:r>
-              <a:t>Problem Statement &amp; Project Motivation</a:t>
-            </a:r>
-          </a:p>
-        </p:txBody>
-      </p:sp>
-      <p:sp>
-        <p:nvSpPr>
-          <p:cNvPr id="6" name="TextBox 5"/>
-          <p:cNvSpPr txBox="1"/>
-          <p:nvPr/>
-        </p:nvSpPr>
-        <p:spPr>
-          <a:xfrm>
-            <a:off x="731520" y="1463040"/>
-            <a:ext cx="5486400" cy="4754880"/>
-          </a:xfrm>
-          <a:prstGeom prst="rect">
-            <a:avLst/>
-          </a:prstGeom>
-          <a:noFill/>
-        </p:spPr>
-        <p:txBody>
-          <a:bodyPr wrap="square">
-            <a:spAutoFit/>
-          </a:bodyPr>
-          <a:lstStyle/>
-          <a:p>
-            <a:pPr>
-              <a:defRPr sz="2000" b="1">
-                <a:solidFill>
-                  <a:srgbClr val="1B4332"/>
-                </a:solidFill>
-              </a:defRPr>
-            </a:pPr>
-            <a:r>
-              <a:t>Why Do Students Need RentEquip?</a:t>
+              <a:t>Challenges College Students Face:</a:t>
             </a:r>
           </a:p>
           <a:p>
             <a:pPr>
               <a:spcBef>
-                <a:spcPts val="1000"/>
+                <a:spcPts val="1200"/>
               </a:spcBef>
             </a:pPr>
             <a:r>
@@ -3641,7 +4101,7 @@
                   <a:srgbClr val="1C2826"/>
                 </a:solidFill>
               </a:rPr>
-              <a:t>Sudden Exam &amp; Lab Emergencies: </a:t>
+              <a:t>• Forgotten Essential Items: </a:t>
             </a:r>
             <a:r>
               <a:rPr sz="1300">
@@ -3649,13 +4109,13 @@
                   <a:srgbClr val="4B5D56"/>
                 </a:solidFill>
               </a:rPr>
-              <a:t>Students frequently forget mandatory items (white lab coats, safety goggles, scientific calculators, or drafters) right before lab sessions or semester finals.</a:t>
+              <a:t>Students frequently forget items like pens, calculators, lab coats, and drawing tools right before tests or practicals.</a:t>
             </a:r>
           </a:p>
           <a:p>
             <a:pPr>
               <a:spcBef>
-                <a:spcPts val="1000"/>
+                <a:spcPts val="1200"/>
               </a:spcBef>
             </a:pPr>
             <a:r>
@@ -3664,7 +4124,7 @@
                   <a:srgbClr val="1C2826"/>
                 </a:solidFill>
               </a:rPr>
-              <a:t>High Cost for Temporary Usage: </a:t>
+              <a:t>• High One-Time Purchase Costs: </a:t>
             </a:r>
             <a:r>
               <a:rPr sz="1300">
@@ -3672,13 +4132,13 @@
                   <a:srgbClr val="4B5D56"/>
                 </a:solidFill>
               </a:rPr>
-              <a:t>Buying a ₹1,500+ Casio fx-991EX calculator, ₹800 drawing board, or ₹600 mini-drafter for a single semester course creates unnecessary financial burden.</a:t>
+              <a:t>Buying equipment like drawing boards or scientific calculators for a single semester is expensive and wasteful.</a:t>
             </a:r>
           </a:p>
           <a:p>
             <a:pPr>
               <a:spcBef>
-                <a:spcPts val="1000"/>
+                <a:spcPts val="1200"/>
               </a:spcBef>
             </a:pPr>
             <a:r>
@@ -3687,7 +4147,7 @@
                   <a:srgbClr val="1C2826"/>
                 </a:solidFill>
               </a:rPr>
-              <a:t>Hostel Clutter &amp; Waste: </a:t>
+              <a:t>• Temporary Academic Needs: </a:t>
             </a:r>
             <a:r>
               <a:rPr sz="1300">
@@ -3695,13 +4155,13 @@
                   <a:srgbClr val="4B5D56"/>
                 </a:solidFill>
               </a:rPr>
-              <a:t>Graduating seniors and higher-semester students have perfectly functional tools gathering dust in hostel rooms with no easy peer-sharing channel.</a:t>
+              <a:t>Students struggle to find specialized tools needed only for short-term project presentations or lab assignments.</a:t>
             </a:r>
           </a:p>
           <a:p>
             <a:pPr>
               <a:spcBef>
-                <a:spcPts val="1000"/>
+                <a:spcPts val="1200"/>
               </a:spcBef>
             </a:pPr>
             <a:r>
@@ -3710,7 +4170,7 @@
                   <a:srgbClr val="1C2826"/>
                 </a:solidFill>
               </a:rPr>
-              <a:t>Campus Circular Economy: </a:t>
+              <a:t>• Lack of Centralized Platform: </a:t>
             </a:r>
             <a:r>
               <a:rPr sz="1300">
@@ -3718,14 +4178,14 @@
                   <a:srgbClr val="4B5D56"/>
                 </a:solidFill>
               </a:rPr>
-              <a:t>RentEquip bridges students needing temporary gear with peers willing to lend, creating affordable access starting from just ₹2/day.</a:t>
+              <a:t>There is no organized, convenient campus marketplace for students to easily borrow or rent items from peers.</a:t>
             </a:r>
           </a:p>
         </p:txBody>
       </p:sp>
       <p:pic>
         <p:nvPicPr>
-          <p:cNvPr id="7" name="Picture 6" descr="slide2_solution.png"/>
+          <p:cNvPr id="8" name="Picture 7" descr="slide2_problem.png"/>
           <p:cNvPicPr>
             <a:picLocks noChangeAspect="1"/>
           </p:cNvPicPr>
@@ -3739,8 +4199,8 @@
         </p:blipFill>
         <p:spPr>
           <a:xfrm>
-            <a:off x="6492240" y="1463040"/>
-            <a:ext cx="5029200" cy="4754880"/>
+            <a:off x="6492240" y="1371600"/>
+            <a:ext cx="5029200" cy="4846320"/>
           </a:xfrm>
           <a:prstGeom prst="rect">
             <a:avLst/>
@@ -3774,7 +4234,7 @@
         <p:spPr>
           <a:xfrm>
             <a:off x="0" y="0"/>
-            <a:ext cx="12191695" cy="1097280"/>
+            <a:ext cx="12191695" cy="1051560"/>
           </a:xfrm>
           <a:prstGeom prst="rect">
             <a:avLst/>
@@ -3816,8 +4276,8 @@
         </p:nvSpPr>
         <p:spPr>
           <a:xfrm>
-            <a:off x="0" y="1097280"/>
-            <a:ext cx="12191695" cy="73152"/>
+            <a:off x="0" y="1051560"/>
+            <a:ext cx="12191695" cy="54864"/>
           </a:xfrm>
           <a:prstGeom prst="rect">
             <a:avLst/>
@@ -3859,8 +4319,113 @@
         </p:nvSpPr>
         <p:spPr>
           <a:xfrm>
-            <a:off x="731520" y="164592"/>
-            <a:ext cx="4572000" cy="274320"/>
+            <a:off x="731520" y="109728"/>
+            <a:ext cx="5486400" cy="256032"/>
+          </a:xfrm>
+          <a:prstGeom prst="rect">
+            <a:avLst/>
+          </a:prstGeom>
+          <a:noFill/>
+        </p:spPr>
+        <p:txBody>
+          <a:bodyPr wrap="none">
+            <a:spAutoFit/>
+          </a:bodyPr>
+          <a:lstStyle/>
+          <a:p>
+            <a:pPr>
+              <a:defRPr sz="1100" b="1">
+                <a:solidFill>
+                  <a:srgbClr val="F59E0B"/>
+                </a:solidFill>
+              </a:defRPr>
+            </a:pPr>
+            <a:r>
+              <a:t>PROJECT OVERVIEW</a:t>
+            </a:r>
+          </a:p>
+        </p:txBody>
+      </p:sp>
+      <p:sp>
+        <p:nvSpPr>
+          <p:cNvPr id="5" name="TextBox 4"/>
+          <p:cNvSpPr txBox="1"/>
+          <p:nvPr/>
+        </p:nvSpPr>
+        <p:spPr>
+          <a:xfrm>
+            <a:off x="731520" y="365760"/>
+            <a:ext cx="8686800" cy="594360"/>
+          </a:xfrm>
+          <a:prstGeom prst="rect">
+            <a:avLst/>
+          </a:prstGeom>
+          <a:noFill/>
+        </p:spPr>
+        <p:txBody>
+          <a:bodyPr wrap="none">
+            <a:spAutoFit/>
+          </a:bodyPr>
+          <a:lstStyle/>
+          <a:p>
+            <a:pPr>
+              <a:defRPr sz="2400" b="1">
+                <a:solidFill>
+                  <a:srgbClr val="FFFFFF"/>
+                </a:solidFill>
+              </a:defRPr>
+            </a:pPr>
+            <a:r>
+              <a:t>Proposed Solution — RentEquip</a:t>
+            </a:r>
+          </a:p>
+        </p:txBody>
+      </p:sp>
+      <p:sp>
+        <p:nvSpPr>
+          <p:cNvPr id="6" name="TextBox 5"/>
+          <p:cNvSpPr txBox="1"/>
+          <p:nvPr/>
+        </p:nvSpPr>
+        <p:spPr>
+          <a:xfrm>
+            <a:off x="10241280" y="320040"/>
+            <a:ext cx="1371600" cy="457200"/>
+          </a:xfrm>
+          <a:prstGeom prst="rect">
+            <a:avLst/>
+          </a:prstGeom>
+          <a:noFill/>
+        </p:spPr>
+        <p:txBody>
+          <a:bodyPr wrap="none">
+            <a:spAutoFit/>
+          </a:bodyPr>
+          <a:lstStyle/>
+          <a:p>
+            <a:pPr algn="r">
+              <a:defRPr sz="1600" b="1">
+                <a:solidFill>
+                  <a:srgbClr val="F59E0B"/>
+                </a:solidFill>
+              </a:defRPr>
+            </a:pPr>
+            <a:r>
+              <a:t>03 / 10</a:t>
+            </a:r>
+          </a:p>
+        </p:txBody>
+      </p:sp>
+      <p:sp>
+        <p:nvSpPr>
+          <p:cNvPr id="7" name="TextBox 6"/>
+          <p:cNvSpPr txBox="1"/>
+          <p:nvPr/>
+        </p:nvSpPr>
+        <p:spPr>
+          <a:xfrm>
+            <a:off x="731520" y="1371600"/>
+            <a:ext cx="5486400" cy="4937760"/>
           </a:xfrm>
           <a:prstGeom prst="rect">
             <a:avLst/>
@@ -3874,90 +4439,20 @@
           <a:lstStyle/>
           <a:p>
             <a:pPr>
-              <a:defRPr sz="1100" b="1">
-                <a:solidFill>
-                  <a:srgbClr val="F59E0B"/>
+              <a:defRPr sz="1900" b="1">
+                <a:solidFill>
+                  <a:srgbClr val="1B4332"/>
                 </a:solidFill>
               </a:defRPr>
             </a:pPr>
             <a:r>
-              <a:t>🎓 CAMPUS-CENTRIC FEATURES</a:t>
-            </a:r>
-          </a:p>
-        </p:txBody>
-      </p:sp>
-      <p:sp>
-        <p:nvSpPr>
-          <p:cNvPr id="5" name="TextBox 4"/>
-          <p:cNvSpPr txBox="1"/>
-          <p:nvPr/>
-        </p:nvSpPr>
-        <p:spPr>
-          <a:xfrm>
-            <a:off x="731520" y="411480"/>
-            <a:ext cx="10058400" cy="548640"/>
-          </a:xfrm>
-          <a:prstGeom prst="rect">
-            <a:avLst/>
-          </a:prstGeom>
-          <a:noFill/>
-        </p:spPr>
-        <p:txBody>
-          <a:bodyPr wrap="square">
-            <a:spAutoFit/>
-          </a:bodyPr>
-          <a:lstStyle/>
-          <a:p>
-            <a:pPr>
-              <a:defRPr sz="2600" b="1">
-                <a:solidFill>
-                  <a:srgbClr val="FFFFFF"/>
-                </a:solidFill>
-              </a:defRPr>
-            </a:pPr>
-            <a:r>
-              <a:t>Core Features &amp; 50+ Campus Inventory</a:t>
-            </a:r>
-          </a:p>
-        </p:txBody>
-      </p:sp>
-      <p:sp>
-        <p:nvSpPr>
-          <p:cNvPr id="6" name="TextBox 5"/>
-          <p:cNvSpPr txBox="1"/>
-          <p:nvPr/>
-        </p:nvSpPr>
-        <p:spPr>
-          <a:xfrm>
-            <a:off x="731520" y="1463040"/>
-            <a:ext cx="5486400" cy="4754880"/>
-          </a:xfrm>
-          <a:prstGeom prst="rect">
-            <a:avLst/>
-          </a:prstGeom>
-          <a:noFill/>
-        </p:spPr>
-        <p:txBody>
-          <a:bodyPr wrap="square">
-            <a:spAutoFit/>
-          </a:bodyPr>
-          <a:lstStyle/>
-          <a:p>
-            <a:pPr>
-              <a:defRPr sz="2000" b="1">
-                <a:solidFill>
-                  <a:srgbClr val="1B4332"/>
-                </a:solidFill>
-              </a:defRPr>
-            </a:pPr>
-            <a:r>
-              <a:t>Built for Daily Student Life</a:t>
+              <a:t>How RentEquip Solves the Problem:</a:t>
             </a:r>
           </a:p>
           <a:p>
             <a:pPr>
               <a:spcBef>
-                <a:spcPts val="1000"/>
+                <a:spcPts val="1200"/>
               </a:spcBef>
             </a:pPr>
             <a:r>
@@ -3966,7 +4461,7 @@
                   <a:srgbClr val="1C2826"/>
                 </a:solidFill>
               </a:rPr>
-              <a:t>10 Comprehensive Categories: </a:t>
+              <a:t>• Peer-to-Peer Campus Marketplace: </a:t>
             </a:r>
             <a:r>
               <a:rPr sz="1300">
@@ -3974,13 +4469,13 @@
                   <a:srgbClr val="4B5D56"/>
                 </a:solidFill>
               </a:rPr>
-              <a:t>Stationery, Engineering Drawing, Lab Essentials, Academic Resources, Electronics, Art &amp; Design, Presentations, Sports, Events, and Everyday Student Essentials.</a:t>
+              <a:t>Connects students who need academic items with students, seniors, and campus clubs who own them.</a:t>
             </a:r>
           </a:p>
           <a:p>
             <a:pPr>
               <a:spcBef>
-                <a:spcPts val="1000"/>
+                <a:spcPts val="1200"/>
               </a:spcBef>
             </a:pPr>
             <a:r>
@@ -3989,7 +4484,7 @@
                   <a:srgbClr val="1C2826"/>
                 </a:solidFill>
               </a:rPr>
-              <a:t>Strategic Campus Pickup Points: </a:t>
+              <a:t>• Search &amp; Rent with Ease: </a:t>
             </a:r>
             <a:r>
               <a:rPr sz="1300">
@@ -3997,13 +4492,13 @@
                   <a:srgbClr val="4B5D56"/>
                 </a:solidFill>
               </a:rPr>
-              <a:t>Collect items within minutes at Central Library Helpdesk, SAC Room 102, Mechanical Workshop, Science Labs, or Hostel Common Rooms.</a:t>
+              <a:t>Students can browse, search, and rent essential items for flexible daily periods at affordable student rates.</a:t>
             </a:r>
           </a:p>
           <a:p>
             <a:pPr>
               <a:spcBef>
-                <a:spcPts val="1000"/>
+                <a:spcPts val="1200"/>
               </a:spcBef>
             </a:pPr>
             <a:r>
@@ -4012,7 +4507,7 @@
                   <a:srgbClr val="1C2826"/>
                 </a:solidFill>
               </a:rPr>
-              <a:t>Real-time Cost &amp; Deposit Engine: </a:t>
+              <a:t>• Lender Tools for Owners: </a:t>
             </a:r>
             <a:r>
               <a:rPr sz="1300">
@@ -4020,13 +4515,13 @@
                   <a:srgbClr val="4B5D56"/>
                 </a:solidFill>
               </a:rPr>
-              <a:t>Dynamic quote calculator displaying daily rate in ₹, 5% student pool fee, and 100% refundable escrow security deposit.</a:t>
+              <a:t>Equipment owners can list spare items, set rental prices and deposits, and manage incoming requests easily.</a:t>
             </a:r>
           </a:p>
           <a:p>
             <a:pPr>
               <a:spcBef>
-                <a:spcPts val="1000"/>
+                <a:spcPts val="1200"/>
               </a:spcBef>
             </a:pPr>
             <a:r>
@@ -4035,7 +4530,7 @@
                   <a:srgbClr val="1C2826"/>
                 </a:solidFill>
               </a:rPr>
-              <a:t>Condition Transparency: </a:t>
+              <a:t>• Single Centralized Platform: </a:t>
             </a:r>
             <a:r>
               <a:rPr sz="1300">
@@ -4043,14 +4538,14 @@
                   <a:srgbClr val="4B5D56"/>
                 </a:solidFill>
               </a:rPr>
-              <a:t>Items labeled by condition (Pristine, Gently Used, Working) with verified student reviews to ensure reliability during critical exams.</a:t>
+              <a:t>A unified website simplifies discovery, date reservation, pickup coordination, and return settlements.</a:t>
             </a:r>
           </a:p>
         </p:txBody>
       </p:sp>
       <p:pic>
         <p:nvPicPr>
-          <p:cNvPr id="7" name="Picture 6" descr="slide3_categories.png"/>
+          <p:cNvPr id="8" name="Picture 7" descr="slide3_solution.png"/>
           <p:cNvPicPr>
             <a:picLocks noChangeAspect="1"/>
           </p:cNvPicPr>
@@ -4064,8 +4559,8 @@
         </p:blipFill>
         <p:spPr>
           <a:xfrm>
-            <a:off x="6492240" y="1463040"/>
-            <a:ext cx="5029200" cy="4754880"/>
+            <a:off x="6492240" y="1371600"/>
+            <a:ext cx="5029200" cy="4846320"/>
           </a:xfrm>
           <a:prstGeom prst="rect">
             <a:avLst/>
@@ -4099,7 +4594,7 @@
         <p:spPr>
           <a:xfrm>
             <a:off x="0" y="0"/>
-            <a:ext cx="12191695" cy="1097280"/>
+            <a:ext cx="12191695" cy="1051560"/>
           </a:xfrm>
           <a:prstGeom prst="rect">
             <a:avLst/>
@@ -4141,8 +4636,8 @@
         </p:nvSpPr>
         <p:spPr>
           <a:xfrm>
-            <a:off x="0" y="1097280"/>
-            <a:ext cx="12191695" cy="73152"/>
+            <a:off x="0" y="1051560"/>
+            <a:ext cx="12191695" cy="54864"/>
           </a:xfrm>
           <a:prstGeom prst="rect">
             <a:avLst/>
@@ -4184,8 +4679,113 @@
         </p:nvSpPr>
         <p:spPr>
           <a:xfrm>
-            <a:off x="731520" y="164592"/>
-            <a:ext cx="4572000" cy="274320"/>
+            <a:off x="731520" y="109728"/>
+            <a:ext cx="5486400" cy="256032"/>
+          </a:xfrm>
+          <a:prstGeom prst="rect">
+            <a:avLst/>
+          </a:prstGeom>
+          <a:noFill/>
+        </p:spPr>
+        <p:txBody>
+          <a:bodyPr wrap="none">
+            <a:spAutoFit/>
+          </a:bodyPr>
+          <a:lstStyle/>
+          <a:p>
+            <a:pPr>
+              <a:defRPr sz="1100" b="1">
+                <a:solidFill>
+                  <a:srgbClr val="F59E0B"/>
+                </a:solidFill>
+              </a:defRPr>
+            </a:pPr>
+            <a:r>
+              <a:t>WHAT STUDENTS CAN DO</a:t>
+            </a:r>
+          </a:p>
+        </p:txBody>
+      </p:sp>
+      <p:sp>
+        <p:nvSpPr>
+          <p:cNvPr id="5" name="TextBox 4"/>
+          <p:cNvSpPr txBox="1"/>
+          <p:nvPr/>
+        </p:nvSpPr>
+        <p:spPr>
+          <a:xfrm>
+            <a:off x="731520" y="365760"/>
+            <a:ext cx="8686800" cy="594360"/>
+          </a:xfrm>
+          <a:prstGeom prst="rect">
+            <a:avLst/>
+          </a:prstGeom>
+          <a:noFill/>
+        </p:spPr>
+        <p:txBody>
+          <a:bodyPr wrap="none">
+            <a:spAutoFit/>
+          </a:bodyPr>
+          <a:lstStyle/>
+          <a:p>
+            <a:pPr>
+              <a:defRPr sz="2400" b="1">
+                <a:solidFill>
+                  <a:srgbClr val="FFFFFF"/>
+                </a:solidFill>
+              </a:defRPr>
+            </a:pPr>
+            <a:r>
+              <a:t>Key Features</a:t>
+            </a:r>
+          </a:p>
+        </p:txBody>
+      </p:sp>
+      <p:sp>
+        <p:nvSpPr>
+          <p:cNvPr id="6" name="TextBox 5"/>
+          <p:cNvSpPr txBox="1"/>
+          <p:nvPr/>
+        </p:nvSpPr>
+        <p:spPr>
+          <a:xfrm>
+            <a:off x="10241280" y="320040"/>
+            <a:ext cx="1371600" cy="457200"/>
+          </a:xfrm>
+          <a:prstGeom prst="rect">
+            <a:avLst/>
+          </a:prstGeom>
+          <a:noFill/>
+        </p:spPr>
+        <p:txBody>
+          <a:bodyPr wrap="none">
+            <a:spAutoFit/>
+          </a:bodyPr>
+          <a:lstStyle/>
+          <a:p>
+            <a:pPr algn="r">
+              <a:defRPr sz="1600" b="1">
+                <a:solidFill>
+                  <a:srgbClr val="F59E0B"/>
+                </a:solidFill>
+              </a:defRPr>
+            </a:pPr>
+            <a:r>
+              <a:t>04 / 10</a:t>
+            </a:r>
+          </a:p>
+        </p:txBody>
+      </p:sp>
+      <p:sp>
+        <p:nvSpPr>
+          <p:cNvPr id="7" name="TextBox 6"/>
+          <p:cNvSpPr txBox="1"/>
+          <p:nvPr/>
+        </p:nvSpPr>
+        <p:spPr>
+          <a:xfrm>
+            <a:off x="731520" y="1371600"/>
+            <a:ext cx="5486400" cy="4937760"/>
           </a:xfrm>
           <a:prstGeom prst="rect">
             <a:avLst/>
@@ -4199,183 +4799,159 @@
           <a:lstStyle/>
           <a:p>
             <a:pPr>
-              <a:defRPr sz="1100" b="1">
-                <a:solidFill>
-                  <a:srgbClr val="F59E0B"/>
+              <a:defRPr sz="1900" b="1">
+                <a:solidFill>
+                  <a:srgbClr val="1B4332"/>
                 </a:solidFill>
               </a:defRPr>
             </a:pPr>
             <a:r>
-              <a:t>🎓 ENGINEERING DETAILS</a:t>
-            </a:r>
-          </a:p>
-        </p:txBody>
-      </p:sp>
-      <p:sp>
-        <p:nvSpPr>
-          <p:cNvPr id="5" name="TextBox 4"/>
-          <p:cNvSpPr txBox="1"/>
-          <p:nvPr/>
-        </p:nvSpPr>
-        <p:spPr>
-          <a:xfrm>
-            <a:off x="731520" y="411480"/>
-            <a:ext cx="10058400" cy="548640"/>
-          </a:xfrm>
-          <a:prstGeom prst="rect">
-            <a:avLst/>
-          </a:prstGeom>
-          <a:noFill/>
-        </p:spPr>
-        <p:txBody>
-          <a:bodyPr wrap="square">
-            <a:spAutoFit/>
-          </a:bodyPr>
-          <a:lstStyle/>
-          <a:p>
-            <a:pPr>
-              <a:defRPr sz="2600" b="1">
-                <a:solidFill>
-                  <a:srgbClr val="FFFFFF"/>
-                </a:solidFill>
-              </a:defRPr>
-            </a:pPr>
-            <a:r>
-              <a:t>Technical Architecture &amp; Zero-Dependency Stack</a:t>
-            </a:r>
-          </a:p>
-        </p:txBody>
-      </p:sp>
-      <p:sp>
-        <p:nvSpPr>
-          <p:cNvPr id="6" name="TextBox 5"/>
-          <p:cNvSpPr txBox="1"/>
-          <p:nvPr/>
-        </p:nvSpPr>
-        <p:spPr>
-          <a:xfrm>
-            <a:off x="731520" y="1463040"/>
-            <a:ext cx="5486400" cy="4754880"/>
-          </a:xfrm>
-          <a:prstGeom prst="rect">
-            <a:avLst/>
-          </a:prstGeom>
-          <a:noFill/>
-        </p:spPr>
-        <p:txBody>
-          <a:bodyPr wrap="square">
-            <a:spAutoFit/>
-          </a:bodyPr>
-          <a:lstStyle/>
-          <a:p>
-            <a:pPr>
-              <a:defRPr sz="2000" b="1">
-                <a:solidFill>
-                  <a:srgbClr val="1B4332"/>
-                </a:solidFill>
-              </a:defRPr>
-            </a:pPr>
-            <a:r>
-              <a:t>Pure Vanilla Web Implementation</a:t>
+              <a:t>Core Application Capabilities:</a:t>
             </a:r>
           </a:p>
           <a:p>
             <a:pPr>
               <a:spcBef>
-                <a:spcPts val="1000"/>
+                <a:spcPts val="800"/>
               </a:spcBef>
             </a:pPr>
             <a:r>
-              <a:rPr b="1" sz="1400">
+              <a:rPr b="1" sz="1300">
                 <a:solidFill>
                   <a:srgbClr val="1C2826"/>
                 </a:solidFill>
               </a:rPr>
-              <a:t>Zero Frameworks &amp; Libraries: </a:t>
-            </a:r>
-            <a:r>
-              <a:rPr sz="1300">
+              <a:t>• Smart Search &amp; Filters: </a:t>
+            </a:r>
+            <a:r>
+              <a:rPr sz="1200">
                 <a:solidFill>
                   <a:srgbClr val="4B5D56"/>
                 </a:solidFill>
               </a:rPr>
-              <a:t>Engineered exclusively with semantic HTML5, modern CSS3 (Flexbox/Grid, tokens), and vanilla ES6+ JavaScript. No npm, React, Vue, or build tools.</a:t>
+              <a:t>Filter equipment by category, daily price budget, availability, and campus pickup locations.</a:t>
             </a:r>
           </a:p>
           <a:p>
             <a:pPr>
               <a:spcBef>
-                <a:spcPts val="1000"/>
+                <a:spcPts val="800"/>
               </a:spcBef>
             </a:pPr>
             <a:r>
-              <a:rPr b="1" sz="1400">
+              <a:rPr b="1" sz="1300">
                 <a:solidFill>
                   <a:srgbClr val="1C2826"/>
                 </a:solidFill>
               </a:rPr>
-              <a:t>LocalStorage Persistence Engine: </a:t>
-            </a:r>
-            <a:r>
-              <a:rPr sz="1300">
+              <a:t>• Diverse Academic Inventory: </a:t>
+            </a:r>
+            <a:r>
+              <a:rPr sz="1200">
                 <a:solidFill>
                   <a:srgbClr val="4B5D56"/>
                 </a:solidFill>
               </a:rPr>
-              <a:t>Complete state repository storing users, 52+ equipment items, bookings, reviews, and notifications in client-side localStorage.</a:t>
+              <a:t>Browse stationery, engineering drawing boards, lab coats, multimeters, tech gear, art sets, and textbooks.</a:t>
             </a:r>
           </a:p>
           <a:p>
             <a:pPr>
               <a:spcBef>
-                <a:spcPts val="1000"/>
+                <a:spcPts val="800"/>
               </a:spcBef>
             </a:pPr>
             <a:r>
-              <a:rPr b="1" sz="1400">
+              <a:rPr b="1" sz="1300">
                 <a:solidFill>
                   <a:srgbClr val="1C2826"/>
                 </a:solidFill>
               </a:rPr>
-              <a:t>Mathematical Conflict Engine: </a:t>
-            </a:r>
-            <a:r>
-              <a:rPr sz="1300">
+              <a:t>• Seamless Rental Requests: </a:t>
+            </a:r>
+            <a:r>
+              <a:rPr sz="1200">
                 <a:solidFill>
                   <a:srgbClr val="4B5D56"/>
                 </a:solidFill>
               </a:rPr>
-              <a:t>Deterministic date interval overlap algorithm (startA &lt;= endB &amp;&amp; startB &lt;= endA) preventing double bookings on confirmed equipment.</a:t>
+              <a:t>Select pickup and return dates, view live cost quotes, and send booking requests with a single click.</a:t>
             </a:r>
           </a:p>
           <a:p>
             <a:pPr>
               <a:spcBef>
-                <a:spcPts val="1000"/>
+                <a:spcPts val="800"/>
               </a:spcBef>
             </a:pPr>
             <a:r>
-              <a:rPr b="1" sz="1400">
+              <a:rPr b="1" sz="1300">
                 <a:solidFill>
                   <a:srgbClr val="1C2826"/>
                 </a:solidFill>
               </a:rPr>
-              <a:t>GitHub Actions CI/CD: </a:t>
-            </a:r>
-            <a:r>
-              <a:rPr sz="1300">
+              <a:t>• Owner Request Management: </a:t>
+            </a:r>
+            <a:r>
+              <a:rPr sz="1200">
                 <a:solidFill>
                   <a:srgbClr val="4B5D56"/>
                 </a:solidFill>
               </a:rPr>
-              <a:t>Automated static deployment workflow (.github/workflows/deploy.yml) with subpath-safe relative paths for instant live hosting.</a:t>
+              <a:t>Hosts can review incoming requests and choose to approve or decline with feedback.</a:t>
+            </a:r>
+          </a:p>
+          <a:p>
+            <a:pPr>
+              <a:spcBef>
+                <a:spcPts val="800"/>
+              </a:spcBef>
+            </a:pPr>
+            <a:r>
+              <a:rPr b="1" sz="1300">
+                <a:solidFill>
+                  <a:srgbClr val="1C2826"/>
+                </a:solidFill>
+              </a:rPr>
+              <a:t>• Deposit &amp; Return Tracking: </a:t>
+            </a:r>
+            <a:r>
+              <a:rPr sz="1200">
+                <a:solidFill>
+                  <a:srgbClr val="4B5D56"/>
+                </a:solidFill>
+              </a:rPr>
+              <a:t>Transparent tracking of refundable security deposits, actual return dates, and condition reports.</a:t>
+            </a:r>
+          </a:p>
+          <a:p>
+            <a:pPr>
+              <a:spcBef>
+                <a:spcPts val="800"/>
+              </a:spcBef>
+            </a:pPr>
+            <a:r>
+              <a:rPr b="1" sz="1300">
+                <a:solidFill>
+                  <a:srgbClr val="1C2826"/>
+                </a:solidFill>
+              </a:rPr>
+              <a:t>• Alerts &amp; Verified Reviews: </a:t>
+            </a:r>
+            <a:r>
+              <a:rPr sz="1200">
+                <a:solidFill>
+                  <a:srgbClr val="4B5D56"/>
+                </a:solidFill>
+              </a:rPr>
+              <a:t>Real-time notifications for booking updates and verified peer reviews for completed rentals.</a:t>
             </a:r>
           </a:p>
         </p:txBody>
       </p:sp>
       <p:pic>
         <p:nvPicPr>
-          <p:cNvPr id="7" name="Picture 6" descr="slide4_architecture.png"/>
+          <p:cNvPr id="8" name="Picture 7" descr="slide4_features.png"/>
           <p:cNvPicPr>
             <a:picLocks noChangeAspect="1"/>
           </p:cNvPicPr>
@@ -4389,8 +4965,8 @@
         </p:blipFill>
         <p:spPr>
           <a:xfrm>
-            <a:off x="6492240" y="1463040"/>
-            <a:ext cx="5029200" cy="4754880"/>
+            <a:off x="6492240" y="1371600"/>
+            <a:ext cx="5029200" cy="4846320"/>
           </a:xfrm>
           <a:prstGeom prst="rect">
             <a:avLst/>
@@ -4424,7 +5000,7 @@
         <p:spPr>
           <a:xfrm>
             <a:off x="0" y="0"/>
-            <a:ext cx="12191695" cy="1097280"/>
+            <a:ext cx="12191695" cy="1051560"/>
           </a:xfrm>
           <a:prstGeom prst="rect">
             <a:avLst/>
@@ -4466,8 +5042,8 @@
         </p:nvSpPr>
         <p:spPr>
           <a:xfrm>
-            <a:off x="0" y="1097280"/>
-            <a:ext cx="12191695" cy="73152"/>
+            <a:off x="0" y="1051560"/>
+            <a:ext cx="12191695" cy="54864"/>
           </a:xfrm>
           <a:prstGeom prst="rect">
             <a:avLst/>
@@ -4509,8 +5085,113 @@
         </p:nvSpPr>
         <p:spPr>
           <a:xfrm>
-            <a:off x="731520" y="164592"/>
-            <a:ext cx="4572000" cy="274320"/>
+            <a:off x="731520" y="109728"/>
+            <a:ext cx="5486400" cy="256032"/>
+          </a:xfrm>
+          <a:prstGeom prst="rect">
+            <a:avLst/>
+          </a:prstGeom>
+          <a:noFill/>
+        </p:spPr>
+        <p:txBody>
+          <a:bodyPr wrap="none">
+            <a:spAutoFit/>
+          </a:bodyPr>
+          <a:lstStyle/>
+          <a:p>
+            <a:pPr>
+              <a:defRPr sz="1100" b="1">
+                <a:solidFill>
+                  <a:srgbClr val="F59E0B"/>
+                </a:solidFill>
+              </a:defRPr>
+            </a:pPr>
+            <a:r>
+              <a:t>END-TO-END RENTAL JOURNEY</a:t>
+            </a:r>
+          </a:p>
+        </p:txBody>
+      </p:sp>
+      <p:sp>
+        <p:nvSpPr>
+          <p:cNvPr id="5" name="TextBox 4"/>
+          <p:cNvSpPr txBox="1"/>
+          <p:nvPr/>
+        </p:nvSpPr>
+        <p:spPr>
+          <a:xfrm>
+            <a:off x="731520" y="365760"/>
+            <a:ext cx="8686800" cy="594360"/>
+          </a:xfrm>
+          <a:prstGeom prst="rect">
+            <a:avLst/>
+          </a:prstGeom>
+          <a:noFill/>
+        </p:spPr>
+        <p:txBody>
+          <a:bodyPr wrap="none">
+            <a:spAutoFit/>
+          </a:bodyPr>
+          <a:lstStyle/>
+          <a:p>
+            <a:pPr>
+              <a:defRPr sz="2400" b="1">
+                <a:solidFill>
+                  <a:srgbClr val="FFFFFF"/>
+                </a:solidFill>
+              </a:defRPr>
+            </a:pPr>
+            <a:r>
+              <a:t>System Workflow</a:t>
+            </a:r>
+          </a:p>
+        </p:txBody>
+      </p:sp>
+      <p:sp>
+        <p:nvSpPr>
+          <p:cNvPr id="6" name="TextBox 5"/>
+          <p:cNvSpPr txBox="1"/>
+          <p:nvPr/>
+        </p:nvSpPr>
+        <p:spPr>
+          <a:xfrm>
+            <a:off x="10241280" y="320040"/>
+            <a:ext cx="1371600" cy="457200"/>
+          </a:xfrm>
+          <a:prstGeom prst="rect">
+            <a:avLst/>
+          </a:prstGeom>
+          <a:noFill/>
+        </p:spPr>
+        <p:txBody>
+          <a:bodyPr wrap="none">
+            <a:spAutoFit/>
+          </a:bodyPr>
+          <a:lstStyle/>
+          <a:p>
+            <a:pPr algn="r">
+              <a:defRPr sz="1600" b="1">
+                <a:solidFill>
+                  <a:srgbClr val="F59E0B"/>
+                </a:solidFill>
+              </a:defRPr>
+            </a:pPr>
+            <a:r>
+              <a:t>05 / 10</a:t>
+            </a:r>
+          </a:p>
+        </p:txBody>
+      </p:sp>
+      <p:sp>
+        <p:nvSpPr>
+          <p:cNvPr id="7" name="TextBox 6"/>
+          <p:cNvSpPr txBox="1"/>
+          <p:nvPr/>
+        </p:nvSpPr>
+        <p:spPr>
+          <a:xfrm>
+            <a:off x="731520" y="1280160"/>
+            <a:ext cx="10789920" cy="640080"/>
           </a:xfrm>
           <a:prstGeom prst="rect">
             <a:avLst/>
@@ -4524,183 +5205,21 @@
           <a:lstStyle/>
           <a:p>
             <a:pPr>
-              <a:defRPr sz="1100" b="1">
-                <a:solidFill>
-                  <a:srgbClr val="F59E0B"/>
+              <a:defRPr sz="1800" b="1">
+                <a:solidFill>
+                  <a:srgbClr val="1B4332"/>
                 </a:solidFill>
               </a:defRPr>
             </a:pPr>
             <a:r>
-              <a:t>🎓 WORKFLOW &amp; STATE MACHINE</a:t>
-            </a:r>
-          </a:p>
-        </p:txBody>
-      </p:sp>
-      <p:sp>
-        <p:nvSpPr>
-          <p:cNvPr id="5" name="TextBox 4"/>
-          <p:cNvSpPr txBox="1"/>
-          <p:nvPr/>
-        </p:nvSpPr>
-        <p:spPr>
-          <a:xfrm>
-            <a:off x="731520" y="411480"/>
-            <a:ext cx="10058400" cy="548640"/>
-          </a:xfrm>
-          <a:prstGeom prst="rect">
-            <a:avLst/>
-          </a:prstGeom>
-          <a:noFill/>
-        </p:spPr>
-        <p:txBody>
-          <a:bodyPr wrap="square">
-            <a:spAutoFit/>
-          </a:bodyPr>
-          <a:lstStyle/>
-          <a:p>
-            <a:pPr>
-              <a:defRPr sz="2600" b="1">
-                <a:solidFill>
-                  <a:srgbClr val="FFFFFF"/>
-                </a:solidFill>
-              </a:defRPr>
-            </a:pPr>
-            <a:r>
-              <a:t>Rental Lifecycle &amp; Multi-Role Ecosystem</a:t>
-            </a:r>
-          </a:p>
-        </p:txBody>
-      </p:sp>
-      <p:sp>
-        <p:nvSpPr>
-          <p:cNvPr id="6" name="TextBox 5"/>
-          <p:cNvSpPr txBox="1"/>
-          <p:nvPr/>
-        </p:nvSpPr>
-        <p:spPr>
-          <a:xfrm>
-            <a:off x="731520" y="1463040"/>
-            <a:ext cx="5486400" cy="4754880"/>
-          </a:xfrm>
-          <a:prstGeom prst="rect">
-            <a:avLst/>
-          </a:prstGeom>
-          <a:noFill/>
-        </p:spPr>
-        <p:txBody>
-          <a:bodyPr wrap="square">
-            <a:spAutoFit/>
-          </a:bodyPr>
-          <a:lstStyle/>
-          <a:p>
-            <a:pPr>
-              <a:defRPr sz="2000" b="1">
-                <a:solidFill>
-                  <a:srgbClr val="1B4332"/>
-                </a:solidFill>
-              </a:defRPr>
-            </a:pPr>
-            <a:r>
-              <a:t>End-to-End State Machine</a:t>
-            </a:r>
-          </a:p>
-          <a:p>
-            <a:pPr>
-              <a:spcBef>
-                <a:spcPts val="1000"/>
-              </a:spcBef>
-            </a:pPr>
-            <a:r>
-              <a:rPr b="1" sz="1400">
-                <a:solidFill>
-                  <a:srgbClr val="1C2826"/>
-                </a:solidFill>
-              </a:rPr>
-              <a:t>Simulated Multi-Role Personas: </a:t>
-            </a:r>
-            <a:r>
-              <a:rPr sz="1300">
-                <a:solidFill>
-                  <a:srgbClr val="4B5D56"/>
-                </a:solidFill>
-              </a:rPr>
-              <a:t>Instant navbar switcher between Aarav Sharma (Student Renter), Priya Patel (Student Lender/Host), and SAC Council (Admin).</a:t>
-            </a:r>
-          </a:p>
-          <a:p>
-            <a:pPr>
-              <a:spcBef>
-                <a:spcPts val="1000"/>
-              </a:spcBef>
-            </a:pPr>
-            <a:r>
-              <a:rPr b="1" sz="1400">
-                <a:solidFill>
-                  <a:srgbClr val="1C2826"/>
-                </a:solidFill>
-              </a:rPr>
-              <a:t>Borrow Lifecycle Stages: </a:t>
-            </a:r>
-            <a:r>
-              <a:rPr sz="1300">
-                <a:solidFill>
-                  <a:srgbClr val="4B5D56"/>
-                </a:solidFill>
-              </a:rPr>
-              <a:t>Pending Request -&gt; Host Approval -&gt; Handover/Active -&gt; Return Trigger -&gt; Condition Check -&gt; Deposit Settlement -&gt; Verified Review.</a:t>
-            </a:r>
-          </a:p>
-          <a:p>
-            <a:pPr>
-              <a:spcBef>
-                <a:spcPts val="1000"/>
-              </a:spcBef>
-            </a:pPr>
-            <a:r>
-              <a:rPr b="1" sz="1400">
-                <a:solidFill>
-                  <a:srgbClr val="1C2826"/>
-                </a:solidFill>
-              </a:rPr>
-              <a:t>Deposit Escrow &amp; Late Fees: </a:t>
-            </a:r>
-            <a:r>
-              <a:rPr sz="1300">
-                <a:solidFill>
-                  <a:srgbClr val="4B5D56"/>
-                </a:solidFill>
-              </a:rPr>
-              <a:t>Automatic late penalty calculation (1.25x daily rate) and wear deductions, ensuring fair protection for student hosts.</a:t>
-            </a:r>
-          </a:p>
-          <a:p>
-            <a:pPr>
-              <a:spcBef>
-                <a:spcPts val="1000"/>
-              </a:spcBef>
-            </a:pPr>
-            <a:r>
-              <a:rPr b="1" sz="1400">
-                <a:solidFill>
-                  <a:srgbClr val="1C2826"/>
-                </a:solidFill>
-              </a:rPr>
-              <a:t>Verified Peer Feedback: </a:t>
-            </a:r>
-            <a:r>
-              <a:rPr sz="1300">
-                <a:solidFill>
-                  <a:srgbClr val="4B5D56"/>
-                </a:solidFill>
-              </a:rPr>
-              <a:t>Strict verification rule: reviews permitted exclusively after an item return has been inspected and completed.</a:t>
+              <a:t>How RentEquip Works: From Search to Return &amp; Review</a:t>
             </a:r>
           </a:p>
         </p:txBody>
       </p:sp>
       <p:pic>
         <p:nvPicPr>
-          <p:cNvPr id="7" name="Picture 6" descr="slide5_lifecycle.png"/>
+          <p:cNvPr id="8" name="Picture 7" descr="slide5_flowchart.png"/>
           <p:cNvPicPr>
             <a:picLocks noChangeAspect="1"/>
           </p:cNvPicPr>
@@ -4714,8 +5233,8 @@
         </p:blipFill>
         <p:spPr>
           <a:xfrm>
-            <a:off x="6492240" y="1463040"/>
-            <a:ext cx="5029200" cy="4754880"/>
+            <a:off x="731520" y="1920240"/>
+            <a:ext cx="10698480" cy="4572000"/>
           </a:xfrm>
           <a:prstGeom prst="rect">
             <a:avLst/>
@@ -4749,7 +5268,7 @@
         <p:spPr>
           <a:xfrm>
             <a:off x="0" y="0"/>
-            <a:ext cx="12191695" cy="1097280"/>
+            <a:ext cx="12191695" cy="1051560"/>
           </a:xfrm>
           <a:prstGeom prst="rect">
             <a:avLst/>
@@ -4791,8 +5310,8 @@
         </p:nvSpPr>
         <p:spPr>
           <a:xfrm>
-            <a:off x="0" y="1097280"/>
-            <a:ext cx="12191695" cy="73152"/>
+            <a:off x="0" y="1051560"/>
+            <a:ext cx="12191695" cy="54864"/>
           </a:xfrm>
           <a:prstGeom prst="rect">
             <a:avLst/>
@@ -4834,8 +5353,113 @@
         </p:nvSpPr>
         <p:spPr>
           <a:xfrm>
-            <a:off x="731520" y="164592"/>
-            <a:ext cx="4572000" cy="274320"/>
+            <a:off x="731520" y="109728"/>
+            <a:ext cx="5486400" cy="256032"/>
+          </a:xfrm>
+          <a:prstGeom prst="rect">
+            <a:avLst/>
+          </a:prstGeom>
+          <a:noFill/>
+        </p:spPr>
+        <p:txBody>
+          <a:bodyPr wrap="none">
+            <a:spAutoFit/>
+          </a:bodyPr>
+          <a:lstStyle/>
+          <a:p>
+            <a:pPr>
+              <a:defRPr sz="1100" b="1">
+                <a:solidFill>
+                  <a:srgbClr val="F59E0B"/>
+                </a:solidFill>
+              </a:defRPr>
+            </a:pPr>
+            <a:r>
+              <a:t>PLATFORM STAKEHOLDERS</a:t>
+            </a:r>
+          </a:p>
+        </p:txBody>
+      </p:sp>
+      <p:sp>
+        <p:nvSpPr>
+          <p:cNvPr id="5" name="TextBox 4"/>
+          <p:cNvSpPr txBox="1"/>
+          <p:nvPr/>
+        </p:nvSpPr>
+        <p:spPr>
+          <a:xfrm>
+            <a:off x="731520" y="365760"/>
+            <a:ext cx="8686800" cy="594360"/>
+          </a:xfrm>
+          <a:prstGeom prst="rect">
+            <a:avLst/>
+          </a:prstGeom>
+          <a:noFill/>
+        </p:spPr>
+        <p:txBody>
+          <a:bodyPr wrap="none">
+            <a:spAutoFit/>
+          </a:bodyPr>
+          <a:lstStyle/>
+          <a:p>
+            <a:pPr>
+              <a:defRPr sz="2400" b="1">
+                <a:solidFill>
+                  <a:srgbClr val="FFFFFF"/>
+                </a:solidFill>
+              </a:defRPr>
+            </a:pPr>
+            <a:r>
+              <a:t>User Roles &amp; Ecosystem</a:t>
+            </a:r>
+          </a:p>
+        </p:txBody>
+      </p:sp>
+      <p:sp>
+        <p:nvSpPr>
+          <p:cNvPr id="6" name="TextBox 5"/>
+          <p:cNvSpPr txBox="1"/>
+          <p:nvPr/>
+        </p:nvSpPr>
+        <p:spPr>
+          <a:xfrm>
+            <a:off x="10241280" y="320040"/>
+            <a:ext cx="1371600" cy="457200"/>
+          </a:xfrm>
+          <a:prstGeom prst="rect">
+            <a:avLst/>
+          </a:prstGeom>
+          <a:noFill/>
+        </p:spPr>
+        <p:txBody>
+          <a:bodyPr wrap="none">
+            <a:spAutoFit/>
+          </a:bodyPr>
+          <a:lstStyle/>
+          <a:p>
+            <a:pPr algn="r">
+              <a:defRPr sz="1600" b="1">
+                <a:solidFill>
+                  <a:srgbClr val="F59E0B"/>
+                </a:solidFill>
+              </a:defRPr>
+            </a:pPr>
+            <a:r>
+              <a:t>06 / 10</a:t>
+            </a:r>
+          </a:p>
+        </p:txBody>
+      </p:sp>
+      <p:sp>
+        <p:nvSpPr>
+          <p:cNvPr id="7" name="TextBox 6"/>
+          <p:cNvSpPr txBox="1"/>
+          <p:nvPr/>
+        </p:nvSpPr>
+        <p:spPr>
+          <a:xfrm>
+            <a:off x="731520" y="1371600"/>
+            <a:ext cx="5486400" cy="4937760"/>
           </a:xfrm>
           <a:prstGeom prst="rect">
             <a:avLst/>
@@ -4849,99 +5473,30 @@
           <a:lstStyle/>
           <a:p>
             <a:pPr>
-              <a:defRPr sz="1100" b="1">
-                <a:solidFill>
-                  <a:srgbClr val="F59E0B"/>
+              <a:defRPr sz="1900" b="1">
+                <a:solidFill>
+                  <a:srgbClr val="1B4332"/>
                 </a:solidFill>
               </a:defRPr>
             </a:pPr>
             <a:r>
-              <a:t>🎓 RESULTS &amp; TAKEAWAYS</a:t>
-            </a:r>
-          </a:p>
-        </p:txBody>
-      </p:sp>
-      <p:sp>
-        <p:nvSpPr>
-          <p:cNvPr id="5" name="TextBox 4"/>
-          <p:cNvSpPr txBox="1"/>
-          <p:nvPr/>
-        </p:nvSpPr>
-        <p:spPr>
-          <a:xfrm>
-            <a:off x="731520" y="411480"/>
-            <a:ext cx="10058400" cy="548640"/>
-          </a:xfrm>
-          <a:prstGeom prst="rect">
-            <a:avLst/>
-          </a:prstGeom>
-          <a:noFill/>
-        </p:spPr>
-        <p:txBody>
-          <a:bodyPr wrap="square">
-            <a:spAutoFit/>
-          </a:bodyPr>
-          <a:lstStyle/>
-          <a:p>
-            <a:pPr>
-              <a:defRPr sz="2600" b="1">
-                <a:solidFill>
-                  <a:srgbClr val="FFFFFF"/>
-                </a:solidFill>
-              </a:defRPr>
-            </a:pPr>
-            <a:r>
-              <a:t>Testing, Verification &amp; Conclusion</a:t>
-            </a:r>
-          </a:p>
-        </p:txBody>
-      </p:sp>
-      <p:sp>
-        <p:nvSpPr>
-          <p:cNvPr id="6" name="TextBox 5"/>
-          <p:cNvSpPr txBox="1"/>
-          <p:nvPr/>
-        </p:nvSpPr>
-        <p:spPr>
-          <a:xfrm>
-            <a:off x="731520" y="1463040"/>
-            <a:ext cx="5486400" cy="4754880"/>
-          </a:xfrm>
-          <a:prstGeom prst="rect">
-            <a:avLst/>
-          </a:prstGeom>
-          <a:noFill/>
-        </p:spPr>
-        <p:txBody>
-          <a:bodyPr wrap="square">
-            <a:spAutoFit/>
-          </a:bodyPr>
-          <a:lstStyle/>
-          <a:p>
-            <a:pPr>
-              <a:defRPr sz="2000" b="1">
-                <a:solidFill>
-                  <a:srgbClr val="1B4332"/>
-                </a:solidFill>
-              </a:defRPr>
-            </a:pPr>
-            <a:r>
-              <a:t>Validated Results &amp; Deliverables</a:t>
+              <a:t>Three Distinct Campus Roles:</a:t>
             </a:r>
           </a:p>
           <a:p>
             <a:pPr>
               <a:spcBef>
-                <a:spcPts val="1000"/>
+                <a:spcPts val="1400"/>
               </a:spcBef>
             </a:pPr>
             <a:r>
-              <a:rPr b="1" sz="1400">
+              <a:rPr b="1" sz="1500">
                 <a:solidFill>
                   <a:srgbClr val="1C2826"/>
                 </a:solidFill>
               </a:rPr>
-              <a:t>176/176 Test Checks Passed: </a:t>
+              <a:t>1. Customer (Student Borrower)
+</a:t>
             </a:r>
             <a:r>
               <a:rPr sz="1300">
@@ -4949,22 +5504,23 @@
                   <a:srgbClr val="4B5D56"/>
                 </a:solidFill>
               </a:rPr>
-              <a:t>Rigorous automated test suite covering financial calculations in ₹, date collision prevention, and DOM binding contracts across all 6 pages.</a:t>
+              <a:t>Searches campus catalog, selects rental duration, submits borrow requests, tracks bookings, confirms pickup, and writes peer reviews.</a:t>
             </a:r>
           </a:p>
           <a:p>
             <a:pPr>
               <a:spcBef>
-                <a:spcPts val="1000"/>
+                <a:spcPts val="1400"/>
               </a:spcBef>
             </a:pPr>
             <a:r>
-              <a:rPr b="1" sz="1400">
+              <a:rPr b="1" sz="1500">
                 <a:solidFill>
                   <a:srgbClr val="1C2826"/>
                 </a:solidFill>
               </a:rPr>
-              <a:t>Responsive Campus Design: </a:t>
+              <a:t>2. Equipment Owner (Student Lender / Senior)
+</a:t>
             </a:r>
             <a:r>
               <a:rPr sz="1300">
@@ -4972,22 +5528,23 @@
                   <a:srgbClr val="4B5D56"/>
                 </a:solidFill>
               </a:rPr>
-              <a:t>Student-friendly notebook cream aesthetic with floating academic doodles, tactile hover cards, status badges, and mobile drawer navigation.</a:t>
+              <a:t>Lists spare academic items, sets daily prices and deposits, approves or declines requests, checks returned items, and releases deposits.</a:t>
             </a:r>
           </a:p>
           <a:p>
             <a:pPr>
               <a:spcBef>
-                <a:spcPts val="1000"/>
+                <a:spcPts val="1400"/>
               </a:spcBef>
             </a:pPr>
             <a:r>
-              <a:rPr b="1" sz="1400">
+              <a:rPr b="1" sz="1500">
                 <a:solidFill>
                   <a:srgbClr val="1C2826"/>
                 </a:solidFill>
               </a:rPr>
-              <a:t>Live GitHub Pages Deployment: </a:t>
+              <a:t>3. Administrator (Student Affairs Council / SAC)
+</a:t>
             </a:r>
             <a:r>
               <a:rPr sz="1300">
@@ -4995,37 +5552,14 @@
                   <a:srgbClr val="4B5D56"/>
                 </a:solidFill>
               </a:rPr>
-              <a:t>Automated CI/CD pipeline deploys static files directly to production upon push to main with subpath compatibility.</a:t>
-            </a:r>
-          </a:p>
-          <a:p>
-            <a:pPr>
-              <a:spcBef>
-                <a:spcPts val="1000"/>
-              </a:spcBef>
-            </a:pPr>
-            <a:r>
-              <a:rPr b="1" sz="1400">
-                <a:solidFill>
-                  <a:srgbClr val="1C2826"/>
-                </a:solidFill>
-              </a:rPr>
-              <a:t>Summary: </a:t>
-            </a:r>
-            <a:r>
-              <a:rPr sz="1300">
-                <a:solidFill>
-                  <a:srgbClr val="4B5D56"/>
-                </a:solidFill>
-              </a:rPr>
-              <a:t>RentEquip demonstrates that modern, rich web applications can be constructed with zero bloated dependencies, providing real-world utility for university campuses.</a:t>
+              <a:t>Oversees platform activity, user registry, campus catalog audit, monitors overdue alerts, and maintains data backups.</a:t>
             </a:r>
           </a:p>
         </p:txBody>
       </p:sp>
       <p:pic>
         <p:nvPicPr>
-          <p:cNvPr id="7" name="Picture 6" descr="slide6_summary.png"/>
+          <p:cNvPr id="8" name="Picture 7" descr="slide6_roles.png"/>
           <p:cNvPicPr>
             <a:picLocks noChangeAspect="1"/>
           </p:cNvPicPr>
@@ -5039,8 +5573,1203 @@
         </p:blipFill>
         <p:spPr>
           <a:xfrm>
-            <a:off x="6492240" y="1463040"/>
-            <a:ext cx="5029200" cy="4754880"/>
+            <a:off x="6492240" y="1371600"/>
+            <a:ext cx="5029200" cy="4846320"/>
+          </a:xfrm>
+          <a:prstGeom prst="rect">
+            <a:avLst/>
+          </a:prstGeom>
+        </p:spPr>
+      </p:pic>
+    </p:spTree>
+  </p:cSld>
+  <p:clrMapOvr>
+    <a:masterClrMapping/>
+  </p:clrMapOvr>
+</p:sld>
+</file>
+
+<file path=ppt/slides/slide7.xml><?xml version="1.0" encoding="utf-8"?>
+<p:sld xmlns:a="http://schemas.openxmlformats.org/drawingml/2006/main" xmlns:p="http://schemas.openxmlformats.org/presentationml/2006/main" xmlns:r="http://schemas.openxmlformats.org/officeDocument/2006/relationships">
+  <p:cSld>
+    <p:spTree>
+      <p:nvGrpSpPr>
+        <p:cNvPr id="1" name=""/>
+        <p:cNvGrpSpPr/>
+        <p:nvPr/>
+      </p:nvGrpSpPr>
+      <p:grpSpPr/>
+      <p:sp>
+        <p:nvSpPr>
+          <p:cNvPr id="2" name="Rectangle 1"/>
+          <p:cNvSpPr/>
+          <p:nvPr/>
+        </p:nvSpPr>
+        <p:spPr>
+          <a:xfrm>
+            <a:off x="0" y="0"/>
+            <a:ext cx="12191695" cy="1051560"/>
+          </a:xfrm>
+          <a:prstGeom prst="rect">
+            <a:avLst/>
+          </a:prstGeom>
+          <a:solidFill>
+            <a:srgbClr val="1B4332"/>
+          </a:solidFill>
+          <a:ln>
+            <a:noFill/>
+          </a:ln>
+        </p:spPr>
+        <p:style>
+          <a:lnRef idx="1">
+            <a:schemeClr val="accent1"/>
+          </a:lnRef>
+          <a:fillRef idx="3">
+            <a:schemeClr val="accent1"/>
+          </a:fillRef>
+          <a:effectRef idx="2">
+            <a:schemeClr val="accent1"/>
+          </a:effectRef>
+          <a:fontRef idx="minor">
+            <a:schemeClr val="lt1"/>
+          </a:fontRef>
+        </p:style>
+        <p:txBody>
+          <a:bodyPr rtlCol="0" anchor="ctr"/>
+          <a:lstStyle/>
+          <a:p>
+            <a:pPr algn="ctr"/>
+          </a:p>
+        </p:txBody>
+      </p:sp>
+      <p:sp>
+        <p:nvSpPr>
+          <p:cNvPr id="3" name="Rectangle 2"/>
+          <p:cNvSpPr/>
+          <p:nvPr/>
+        </p:nvSpPr>
+        <p:spPr>
+          <a:xfrm>
+            <a:off x="0" y="1051560"/>
+            <a:ext cx="12191695" cy="54864"/>
+          </a:xfrm>
+          <a:prstGeom prst="rect">
+            <a:avLst/>
+          </a:prstGeom>
+          <a:solidFill>
+            <a:srgbClr val="FF6B35"/>
+          </a:solidFill>
+          <a:ln>
+            <a:noFill/>
+          </a:ln>
+        </p:spPr>
+        <p:style>
+          <a:lnRef idx="1">
+            <a:schemeClr val="accent1"/>
+          </a:lnRef>
+          <a:fillRef idx="3">
+            <a:schemeClr val="accent1"/>
+          </a:fillRef>
+          <a:effectRef idx="2">
+            <a:schemeClr val="accent1"/>
+          </a:effectRef>
+          <a:fontRef idx="minor">
+            <a:schemeClr val="lt1"/>
+          </a:fontRef>
+        </p:style>
+        <p:txBody>
+          <a:bodyPr rtlCol="0" anchor="ctr"/>
+          <a:lstStyle/>
+          <a:p>
+            <a:pPr algn="ctr"/>
+          </a:p>
+        </p:txBody>
+      </p:sp>
+      <p:sp>
+        <p:nvSpPr>
+          <p:cNvPr id="4" name="TextBox 3"/>
+          <p:cNvSpPr txBox="1"/>
+          <p:nvPr/>
+        </p:nvSpPr>
+        <p:spPr>
+          <a:xfrm>
+            <a:off x="731520" y="109728"/>
+            <a:ext cx="5486400" cy="256032"/>
+          </a:xfrm>
+          <a:prstGeom prst="rect">
+            <a:avLst/>
+          </a:prstGeom>
+          <a:noFill/>
+        </p:spPr>
+        <p:txBody>
+          <a:bodyPr wrap="none">
+            <a:spAutoFit/>
+          </a:bodyPr>
+          <a:lstStyle/>
+          <a:p>
+            <a:pPr>
+              <a:defRPr sz="1100" b="1">
+                <a:solidFill>
+                  <a:srgbClr val="F59E0B"/>
+                </a:solidFill>
+              </a:defRPr>
+            </a:pPr>
+            <a:r>
+              <a:t>SIMPLE WEB ARCHITECTURE</a:t>
+            </a:r>
+          </a:p>
+        </p:txBody>
+      </p:sp>
+      <p:sp>
+        <p:nvSpPr>
+          <p:cNvPr id="5" name="TextBox 4"/>
+          <p:cNvSpPr txBox="1"/>
+          <p:nvPr/>
+        </p:nvSpPr>
+        <p:spPr>
+          <a:xfrm>
+            <a:off x="731520" y="365760"/>
+            <a:ext cx="8686800" cy="594360"/>
+          </a:xfrm>
+          <a:prstGeom prst="rect">
+            <a:avLst/>
+          </a:prstGeom>
+          <a:noFill/>
+        </p:spPr>
+        <p:txBody>
+          <a:bodyPr wrap="none">
+            <a:spAutoFit/>
+          </a:bodyPr>
+          <a:lstStyle/>
+          <a:p>
+            <a:pPr>
+              <a:defRPr sz="2400" b="1">
+                <a:solidFill>
+                  <a:srgbClr val="FFFFFF"/>
+                </a:solidFill>
+              </a:defRPr>
+            </a:pPr>
+            <a:r>
+              <a:t>Technology Used</a:t>
+            </a:r>
+          </a:p>
+        </p:txBody>
+      </p:sp>
+      <p:sp>
+        <p:nvSpPr>
+          <p:cNvPr id="6" name="TextBox 5"/>
+          <p:cNvSpPr txBox="1"/>
+          <p:nvPr/>
+        </p:nvSpPr>
+        <p:spPr>
+          <a:xfrm>
+            <a:off x="10241280" y="320040"/>
+            <a:ext cx="1371600" cy="457200"/>
+          </a:xfrm>
+          <a:prstGeom prst="rect">
+            <a:avLst/>
+          </a:prstGeom>
+          <a:noFill/>
+        </p:spPr>
+        <p:txBody>
+          <a:bodyPr wrap="none">
+            <a:spAutoFit/>
+          </a:bodyPr>
+          <a:lstStyle/>
+          <a:p>
+            <a:pPr algn="r">
+              <a:defRPr sz="1600" b="1">
+                <a:solidFill>
+                  <a:srgbClr val="F59E0B"/>
+                </a:solidFill>
+              </a:defRPr>
+            </a:pPr>
+            <a:r>
+              <a:t>07 / 10</a:t>
+            </a:r>
+          </a:p>
+        </p:txBody>
+      </p:sp>
+      <p:sp>
+        <p:nvSpPr>
+          <p:cNvPr id="7" name="TextBox 6"/>
+          <p:cNvSpPr txBox="1"/>
+          <p:nvPr/>
+        </p:nvSpPr>
+        <p:spPr>
+          <a:xfrm>
+            <a:off x="731520" y="1371600"/>
+            <a:ext cx="5486400" cy="4937760"/>
+          </a:xfrm>
+          <a:prstGeom prst="rect">
+            <a:avLst/>
+          </a:prstGeom>
+          <a:noFill/>
+        </p:spPr>
+        <p:txBody>
+          <a:bodyPr wrap="square">
+            <a:spAutoFit/>
+          </a:bodyPr>
+          <a:lstStyle/>
+          <a:p>
+            <a:pPr>
+              <a:defRPr sz="1900" b="1">
+                <a:solidFill>
+                  <a:srgbClr val="1B4332"/>
+                </a:solidFill>
+              </a:defRPr>
+            </a:pPr>
+            <a:r>
+              <a:t>Built with Core Web Technologies:</a:t>
+            </a:r>
+          </a:p>
+          <a:p>
+            <a:pPr>
+              <a:spcBef>
+                <a:spcPts val="800"/>
+              </a:spcBef>
+            </a:pPr>
+            <a:r>
+              <a:rPr b="1" sz="1300">
+                <a:solidFill>
+                  <a:srgbClr val="1C2826"/>
+                </a:solidFill>
+              </a:rPr>
+              <a:t>• HTML: </a:t>
+            </a:r>
+            <a:r>
+              <a:rPr sz="1200">
+                <a:solidFill>
+                  <a:srgbClr val="4B5D56"/>
+                </a:solidFill>
+              </a:rPr>
+              <a:t>Builds the web pages, accessible forms, modal structures, and semantic layouts.</a:t>
+            </a:r>
+          </a:p>
+          <a:p>
+            <a:pPr>
+              <a:spcBef>
+                <a:spcPts val="800"/>
+              </a:spcBef>
+            </a:pPr>
+            <a:r>
+              <a:rPr b="1" sz="1300">
+                <a:solidFill>
+                  <a:srgbClr val="1C2826"/>
+                </a:solidFill>
+              </a:rPr>
+              <a:t>• CSS: </a:t>
+            </a:r>
+            <a:r>
+              <a:rPr sz="1200">
+                <a:solidFill>
+                  <a:srgbClr val="4B5D56"/>
+                </a:solidFill>
+              </a:rPr>
+              <a:t>Provides the campus notebook visual design, responsive layouts (Flexbox &amp; Grid), and smooth animations.</a:t>
+            </a:r>
+          </a:p>
+          <a:p>
+            <a:pPr>
+              <a:spcBef>
+                <a:spcPts val="800"/>
+              </a:spcBef>
+            </a:pPr>
+            <a:r>
+              <a:rPr b="1" sz="1300">
+                <a:solidFill>
+                  <a:srgbClr val="1C2826"/>
+                </a:solidFill>
+              </a:rPr>
+              <a:t>• JavaScript (Vanilla ES6): </a:t>
+            </a:r>
+            <a:r>
+              <a:rPr sz="1200">
+                <a:solidFill>
+                  <a:srgbClr val="4B5D56"/>
+                </a:solidFill>
+              </a:rPr>
+              <a:t>Handles user interactions, real-time rental calculations, date conflict checking, and page navigation.</a:t>
+            </a:r>
+          </a:p>
+          <a:p>
+            <a:pPr>
+              <a:spcBef>
+                <a:spcPts val="800"/>
+              </a:spcBef>
+            </a:pPr>
+            <a:r>
+              <a:rPr b="1" sz="1300">
+                <a:solidFill>
+                  <a:srgbClr val="1C2826"/>
+                </a:solidFill>
+              </a:rPr>
+              <a:t>• Browser localStorage: </a:t>
+            </a:r>
+            <a:r>
+              <a:rPr sz="1200">
+                <a:solidFill>
+                  <a:srgbClr val="4B5D56"/>
+                </a:solidFill>
+              </a:rPr>
+              <a:t>Saves all demonstration data (equipment, bookings, users, and reviews) directly in the browser with zero backend.</a:t>
+            </a:r>
+          </a:p>
+          <a:p>
+            <a:pPr>
+              <a:spcBef>
+                <a:spcPts val="800"/>
+              </a:spcBef>
+            </a:pPr>
+            <a:r>
+              <a:rPr b="1" sz="1300">
+                <a:solidFill>
+                  <a:srgbClr val="1C2826"/>
+                </a:solidFill>
+              </a:rPr>
+              <a:t>• GitHub &amp; GitHub Actions: </a:t>
+            </a:r>
+            <a:r>
+              <a:rPr sz="1200">
+                <a:solidFill>
+                  <a:srgbClr val="4B5D56"/>
+                </a:solidFill>
+              </a:rPr>
+              <a:t>Hosts source code repository and runs automated CI/CD deployment on every push to main.</a:t>
+            </a:r>
+          </a:p>
+          <a:p>
+            <a:pPr>
+              <a:spcBef>
+                <a:spcPts val="800"/>
+              </a:spcBef>
+            </a:pPr>
+            <a:r>
+              <a:rPr b="1" sz="1300">
+                <a:solidFill>
+                  <a:srgbClr val="1C2826"/>
+                </a:solidFill>
+              </a:rPr>
+              <a:t>• GitHub Pages: </a:t>
+            </a:r>
+            <a:r>
+              <a:rPr sz="1200">
+                <a:solidFill>
+                  <a:srgbClr val="4B5D56"/>
+                </a:solidFill>
+              </a:rPr>
+              <a:t>Deploys and hosts the static website online with a publicly accessible URL.</a:t>
+            </a:r>
+          </a:p>
+        </p:txBody>
+      </p:sp>
+      <p:pic>
+        <p:nvPicPr>
+          <p:cNvPr id="8" name="Picture 7" descr="slide7_tech.png"/>
+          <p:cNvPicPr>
+            <a:picLocks noChangeAspect="1"/>
+          </p:cNvPicPr>
+          <p:nvPr/>
+        </p:nvPicPr>
+        <p:blipFill>
+          <a:blip r:embed="rId2"/>
+          <a:stretch>
+            <a:fillRect/>
+          </a:stretch>
+        </p:blipFill>
+        <p:spPr>
+          <a:xfrm>
+            <a:off x="6492240" y="1371600"/>
+            <a:ext cx="5029200" cy="4846320"/>
+          </a:xfrm>
+          <a:prstGeom prst="rect">
+            <a:avLst/>
+          </a:prstGeom>
+        </p:spPr>
+      </p:pic>
+    </p:spTree>
+  </p:cSld>
+  <p:clrMapOvr>
+    <a:masterClrMapping/>
+  </p:clrMapOvr>
+</p:sld>
+</file>
+
+<file path=ppt/slides/slide8.xml><?xml version="1.0" encoding="utf-8"?>
+<p:sld xmlns:a="http://schemas.openxmlformats.org/drawingml/2006/main" xmlns:p="http://schemas.openxmlformats.org/presentationml/2006/main" xmlns:r="http://schemas.openxmlformats.org/officeDocument/2006/relationships">
+  <p:cSld>
+    <p:spTree>
+      <p:nvGrpSpPr>
+        <p:cNvPr id="1" name=""/>
+        <p:cNvGrpSpPr/>
+        <p:nvPr/>
+      </p:nvGrpSpPr>
+      <p:grpSpPr/>
+      <p:sp>
+        <p:nvSpPr>
+          <p:cNvPr id="2" name="Rectangle 1"/>
+          <p:cNvSpPr/>
+          <p:nvPr/>
+        </p:nvSpPr>
+        <p:spPr>
+          <a:xfrm>
+            <a:off x="0" y="0"/>
+            <a:ext cx="12191695" cy="1051560"/>
+          </a:xfrm>
+          <a:prstGeom prst="rect">
+            <a:avLst/>
+          </a:prstGeom>
+          <a:solidFill>
+            <a:srgbClr val="1B4332"/>
+          </a:solidFill>
+          <a:ln>
+            <a:noFill/>
+          </a:ln>
+        </p:spPr>
+        <p:style>
+          <a:lnRef idx="1">
+            <a:schemeClr val="accent1"/>
+          </a:lnRef>
+          <a:fillRef idx="3">
+            <a:schemeClr val="accent1"/>
+          </a:fillRef>
+          <a:effectRef idx="2">
+            <a:schemeClr val="accent1"/>
+          </a:effectRef>
+          <a:fontRef idx="minor">
+            <a:schemeClr val="lt1"/>
+          </a:fontRef>
+        </p:style>
+        <p:txBody>
+          <a:bodyPr rtlCol="0" anchor="ctr"/>
+          <a:lstStyle/>
+          <a:p>
+            <a:pPr algn="ctr"/>
+          </a:p>
+        </p:txBody>
+      </p:sp>
+      <p:sp>
+        <p:nvSpPr>
+          <p:cNvPr id="3" name="Rectangle 2"/>
+          <p:cNvSpPr/>
+          <p:nvPr/>
+        </p:nvSpPr>
+        <p:spPr>
+          <a:xfrm>
+            <a:off x="0" y="1051560"/>
+            <a:ext cx="12191695" cy="54864"/>
+          </a:xfrm>
+          <a:prstGeom prst="rect">
+            <a:avLst/>
+          </a:prstGeom>
+          <a:solidFill>
+            <a:srgbClr val="FF6B35"/>
+          </a:solidFill>
+          <a:ln>
+            <a:noFill/>
+          </a:ln>
+        </p:spPr>
+        <p:style>
+          <a:lnRef idx="1">
+            <a:schemeClr val="accent1"/>
+          </a:lnRef>
+          <a:fillRef idx="3">
+            <a:schemeClr val="accent1"/>
+          </a:fillRef>
+          <a:effectRef idx="2">
+            <a:schemeClr val="accent1"/>
+          </a:effectRef>
+          <a:fontRef idx="minor">
+            <a:schemeClr val="lt1"/>
+          </a:fontRef>
+        </p:style>
+        <p:txBody>
+          <a:bodyPr rtlCol="0" anchor="ctr"/>
+          <a:lstStyle/>
+          <a:p>
+            <a:pPr algn="ctr"/>
+          </a:p>
+        </p:txBody>
+      </p:sp>
+      <p:sp>
+        <p:nvSpPr>
+          <p:cNvPr id="4" name="TextBox 3"/>
+          <p:cNvSpPr txBox="1"/>
+          <p:nvPr/>
+        </p:nvSpPr>
+        <p:spPr>
+          <a:xfrm>
+            <a:off x="731520" y="109728"/>
+            <a:ext cx="5486400" cy="256032"/>
+          </a:xfrm>
+          <a:prstGeom prst="rect">
+            <a:avLst/>
+          </a:prstGeom>
+          <a:noFill/>
+        </p:spPr>
+        <p:txBody>
+          <a:bodyPr wrap="none">
+            <a:spAutoFit/>
+          </a:bodyPr>
+          <a:lstStyle/>
+          <a:p>
+            <a:pPr>
+              <a:defRPr sz="1100" b="1">
+                <a:solidFill>
+                  <a:srgbClr val="F59E0B"/>
+                </a:solidFill>
+              </a:defRPr>
+            </a:pPr>
+            <a:r>
+              <a:t>HOSTING &amp; DELIVERY</a:t>
+            </a:r>
+          </a:p>
+        </p:txBody>
+      </p:sp>
+      <p:sp>
+        <p:nvSpPr>
+          <p:cNvPr id="5" name="TextBox 4"/>
+          <p:cNvSpPr txBox="1"/>
+          <p:nvPr/>
+        </p:nvSpPr>
+        <p:spPr>
+          <a:xfrm>
+            <a:off x="731520" y="365760"/>
+            <a:ext cx="8686800" cy="594360"/>
+          </a:xfrm>
+          <a:prstGeom prst="rect">
+            <a:avLst/>
+          </a:prstGeom>
+          <a:noFill/>
+        </p:spPr>
+        <p:txBody>
+          <a:bodyPr wrap="none">
+            <a:spAutoFit/>
+          </a:bodyPr>
+          <a:lstStyle/>
+          <a:p>
+            <a:pPr>
+              <a:defRPr sz="2400" b="1">
+                <a:solidFill>
+                  <a:srgbClr val="FFFFFF"/>
+                </a:solidFill>
+              </a:defRPr>
+            </a:pPr>
+            <a:r>
+              <a:t>Deployment &amp; Accessibility</a:t>
+            </a:r>
+          </a:p>
+        </p:txBody>
+      </p:sp>
+      <p:sp>
+        <p:nvSpPr>
+          <p:cNvPr id="6" name="TextBox 5"/>
+          <p:cNvSpPr txBox="1"/>
+          <p:nvPr/>
+        </p:nvSpPr>
+        <p:spPr>
+          <a:xfrm>
+            <a:off x="10241280" y="320040"/>
+            <a:ext cx="1371600" cy="457200"/>
+          </a:xfrm>
+          <a:prstGeom prst="rect">
+            <a:avLst/>
+          </a:prstGeom>
+          <a:noFill/>
+        </p:spPr>
+        <p:txBody>
+          <a:bodyPr wrap="none">
+            <a:spAutoFit/>
+          </a:bodyPr>
+          <a:lstStyle/>
+          <a:p>
+            <a:pPr algn="r">
+              <a:defRPr sz="1600" b="1">
+                <a:solidFill>
+                  <a:srgbClr val="F59E0B"/>
+                </a:solidFill>
+              </a:defRPr>
+            </a:pPr>
+            <a:r>
+              <a:t>08 / 10</a:t>
+            </a:r>
+          </a:p>
+        </p:txBody>
+      </p:sp>
+      <p:sp>
+        <p:nvSpPr>
+          <p:cNvPr id="7" name="TextBox 6"/>
+          <p:cNvSpPr txBox="1"/>
+          <p:nvPr/>
+        </p:nvSpPr>
+        <p:spPr>
+          <a:xfrm>
+            <a:off x="731520" y="1371600"/>
+            <a:ext cx="5486400" cy="4937760"/>
+          </a:xfrm>
+          <a:prstGeom prst="rect">
+            <a:avLst/>
+          </a:prstGeom>
+          <a:noFill/>
+        </p:spPr>
+        <p:txBody>
+          <a:bodyPr wrap="square">
+            <a:spAutoFit/>
+          </a:bodyPr>
+          <a:lstStyle/>
+          <a:p>
+            <a:pPr>
+              <a:defRPr sz="1900" b="1">
+                <a:solidFill>
+                  <a:srgbClr val="1B4332"/>
+                </a:solidFill>
+              </a:defRPr>
+            </a:pPr>
+            <a:r>
+              <a:t>How Users Access RentEquip:</a:t>
+            </a:r>
+          </a:p>
+          <a:p>
+            <a:pPr>
+              <a:spcBef>
+                <a:spcPts val="1200"/>
+              </a:spcBef>
+            </a:pPr>
+            <a:r>
+              <a:rPr b="1" sz="1400">
+                <a:solidFill>
+                  <a:srgbClr val="1C2826"/>
+                </a:solidFill>
+              </a:rPr>
+              <a:t>• Hosted on GitHub Pages: </a:t>
+            </a:r>
+            <a:r>
+              <a:rPr sz="1300">
+                <a:solidFill>
+                  <a:srgbClr val="4B5D56"/>
+                </a:solidFill>
+              </a:rPr>
+              <a:t>The website is deployed live using GitHub Pages infrastructure, ensuring high availability.</a:t>
+            </a:r>
+          </a:p>
+          <a:p>
+            <a:pPr>
+              <a:spcBef>
+                <a:spcPts val="1200"/>
+              </a:spcBef>
+            </a:pPr>
+            <a:r>
+              <a:rPr b="1" sz="1400">
+                <a:solidFill>
+                  <a:srgbClr val="1C2826"/>
+                </a:solidFill>
+              </a:rPr>
+              <a:t>• Accessible via Public URL: </a:t>
+            </a:r>
+            <a:r>
+              <a:rPr sz="1300">
+                <a:solidFill>
+                  <a:srgbClr val="4B5D56"/>
+                </a:solidFill>
+              </a:rPr>
+              <a:t>Students and faculty can access the marketplace directly through a standard web link.</a:t>
+            </a:r>
+          </a:p>
+          <a:p>
+            <a:pPr>
+              <a:spcBef>
+                <a:spcPts val="1200"/>
+              </a:spcBef>
+            </a:pPr>
+            <a:r>
+              <a:rPr b="1" sz="1400">
+                <a:solidFill>
+                  <a:srgbClr val="1C2826"/>
+                </a:solidFill>
+              </a:rPr>
+              <a:t>• No Installation Required: </a:t>
+            </a:r>
+            <a:r>
+              <a:rPr sz="1300">
+                <a:solidFill>
+                  <a:srgbClr val="4B5D56"/>
+                </a:solidFill>
+              </a:rPr>
+              <a:t>Zero client setup needed — runs immediately in any modern desktop or mobile web browser.</a:t>
+            </a:r>
+          </a:p>
+          <a:p>
+            <a:pPr>
+              <a:spcBef>
+                <a:spcPts val="1200"/>
+              </a:spcBef>
+            </a:pPr>
+            <a:r>
+              <a:rPr b="1" sz="1400">
+                <a:solidFill>
+                  <a:srgbClr val="1C2826"/>
+                </a:solidFill>
+              </a:rPr>
+              <a:t>• Cross-Device Responsive: </a:t>
+            </a:r>
+            <a:r>
+              <a:rPr sz="1300">
+                <a:solidFill>
+                  <a:srgbClr val="4B5D56"/>
+                </a:solidFill>
+              </a:rPr>
+              <a:t>Clean adaptive layouts tailored for smartphones, tablets, and laptops.</a:t>
+            </a:r>
+          </a:p>
+          <a:p>
+            <a:pPr>
+              <a:spcBef>
+                <a:spcPts val="1200"/>
+              </a:spcBef>
+            </a:pPr>
+            <a:r>
+              <a:rPr b="1" sz="1400">
+                <a:solidFill>
+                  <a:srgbClr val="1C2826"/>
+                </a:solidFill>
+              </a:rPr>
+              <a:t>• Automated Updates: </a:t>
+            </a:r>
+            <a:r>
+              <a:rPr sz="1300">
+                <a:solidFill>
+                  <a:srgbClr val="4B5D56"/>
+                </a:solidFill>
+              </a:rPr>
+              <a:t>Pushing updates to the main branch automatically triggers GitHub Actions to publish changes live.</a:t>
+            </a:r>
+          </a:p>
+        </p:txBody>
+      </p:sp>
+      <p:pic>
+        <p:nvPicPr>
+          <p:cNvPr id="8" name="Picture 7" descr="slide8_deploy.png"/>
+          <p:cNvPicPr>
+            <a:picLocks noChangeAspect="1"/>
+          </p:cNvPicPr>
+          <p:nvPr/>
+        </p:nvPicPr>
+        <p:blipFill>
+          <a:blip r:embed="rId2"/>
+          <a:stretch>
+            <a:fillRect/>
+          </a:stretch>
+        </p:blipFill>
+        <p:spPr>
+          <a:xfrm>
+            <a:off x="6492240" y="1371600"/>
+            <a:ext cx="5029200" cy="4846320"/>
+          </a:xfrm>
+          <a:prstGeom prst="rect">
+            <a:avLst/>
+          </a:prstGeom>
+        </p:spPr>
+      </p:pic>
+    </p:spTree>
+  </p:cSld>
+  <p:clrMapOvr>
+    <a:masterClrMapping/>
+  </p:clrMapOvr>
+</p:sld>
+</file>
+
+<file path=ppt/slides/slide9.xml><?xml version="1.0" encoding="utf-8"?>
+<p:sld xmlns:a="http://schemas.openxmlformats.org/drawingml/2006/main" xmlns:p="http://schemas.openxmlformats.org/presentationml/2006/main" xmlns:r="http://schemas.openxmlformats.org/officeDocument/2006/relationships">
+  <p:cSld>
+    <p:spTree>
+      <p:nvGrpSpPr>
+        <p:cNvPr id="1" name=""/>
+        <p:cNvGrpSpPr/>
+        <p:nvPr/>
+      </p:nvGrpSpPr>
+      <p:grpSpPr/>
+      <p:sp>
+        <p:nvSpPr>
+          <p:cNvPr id="2" name="Rectangle 1"/>
+          <p:cNvSpPr/>
+          <p:nvPr/>
+        </p:nvSpPr>
+        <p:spPr>
+          <a:xfrm>
+            <a:off x="0" y="0"/>
+            <a:ext cx="12191695" cy="1051560"/>
+          </a:xfrm>
+          <a:prstGeom prst="rect">
+            <a:avLst/>
+          </a:prstGeom>
+          <a:solidFill>
+            <a:srgbClr val="1B4332"/>
+          </a:solidFill>
+          <a:ln>
+            <a:noFill/>
+          </a:ln>
+        </p:spPr>
+        <p:style>
+          <a:lnRef idx="1">
+            <a:schemeClr val="accent1"/>
+          </a:lnRef>
+          <a:fillRef idx="3">
+            <a:schemeClr val="accent1"/>
+          </a:fillRef>
+          <a:effectRef idx="2">
+            <a:schemeClr val="accent1"/>
+          </a:effectRef>
+          <a:fontRef idx="minor">
+            <a:schemeClr val="lt1"/>
+          </a:fontRef>
+        </p:style>
+        <p:txBody>
+          <a:bodyPr rtlCol="0" anchor="ctr"/>
+          <a:lstStyle/>
+          <a:p>
+            <a:pPr algn="ctr"/>
+          </a:p>
+        </p:txBody>
+      </p:sp>
+      <p:sp>
+        <p:nvSpPr>
+          <p:cNvPr id="3" name="Rectangle 2"/>
+          <p:cNvSpPr/>
+          <p:nvPr/>
+        </p:nvSpPr>
+        <p:spPr>
+          <a:xfrm>
+            <a:off x="0" y="1051560"/>
+            <a:ext cx="12191695" cy="54864"/>
+          </a:xfrm>
+          <a:prstGeom prst="rect">
+            <a:avLst/>
+          </a:prstGeom>
+          <a:solidFill>
+            <a:srgbClr val="FF6B35"/>
+          </a:solidFill>
+          <a:ln>
+            <a:noFill/>
+          </a:ln>
+        </p:spPr>
+        <p:style>
+          <a:lnRef idx="1">
+            <a:schemeClr val="accent1"/>
+          </a:lnRef>
+          <a:fillRef idx="3">
+            <a:schemeClr val="accent1"/>
+          </a:fillRef>
+          <a:effectRef idx="2">
+            <a:schemeClr val="accent1"/>
+          </a:effectRef>
+          <a:fontRef idx="minor">
+            <a:schemeClr val="lt1"/>
+          </a:fontRef>
+        </p:style>
+        <p:txBody>
+          <a:bodyPr rtlCol="0" anchor="ctr"/>
+          <a:lstStyle/>
+          <a:p>
+            <a:pPr algn="ctr"/>
+          </a:p>
+        </p:txBody>
+      </p:sp>
+      <p:sp>
+        <p:nvSpPr>
+          <p:cNvPr id="4" name="TextBox 3"/>
+          <p:cNvSpPr txBox="1"/>
+          <p:nvPr/>
+        </p:nvSpPr>
+        <p:spPr>
+          <a:xfrm>
+            <a:off x="731520" y="109728"/>
+            <a:ext cx="5486400" cy="256032"/>
+          </a:xfrm>
+          <a:prstGeom prst="rect">
+            <a:avLst/>
+          </a:prstGeom>
+          <a:noFill/>
+        </p:spPr>
+        <p:txBody>
+          <a:bodyPr wrap="none">
+            <a:spAutoFit/>
+          </a:bodyPr>
+          <a:lstStyle/>
+          <a:p>
+            <a:pPr>
+              <a:defRPr sz="1100" b="1">
+                <a:solidFill>
+                  <a:srgbClr val="F59E0B"/>
+                </a:solidFill>
+              </a:defRPr>
+            </a:pPr>
+            <a:r>
+              <a:t>PROJECT IMPACT &amp; EVOLUTION</a:t>
+            </a:r>
+          </a:p>
+        </p:txBody>
+      </p:sp>
+      <p:sp>
+        <p:nvSpPr>
+          <p:cNvPr id="5" name="TextBox 4"/>
+          <p:cNvSpPr txBox="1"/>
+          <p:nvPr/>
+        </p:nvSpPr>
+        <p:spPr>
+          <a:xfrm>
+            <a:off x="731520" y="365760"/>
+            <a:ext cx="8686800" cy="594360"/>
+          </a:xfrm>
+          <a:prstGeom prst="rect">
+            <a:avLst/>
+          </a:prstGeom>
+          <a:noFill/>
+        </p:spPr>
+        <p:txBody>
+          <a:bodyPr wrap="none">
+            <a:spAutoFit/>
+          </a:bodyPr>
+          <a:lstStyle/>
+          <a:p>
+            <a:pPr>
+              <a:defRPr sz="2400" b="1">
+                <a:solidFill>
+                  <a:srgbClr val="FFFFFF"/>
+                </a:solidFill>
+              </a:defRPr>
+            </a:pPr>
+            <a:r>
+              <a:t>Benefits &amp; Future Scope</a:t>
+            </a:r>
+          </a:p>
+        </p:txBody>
+      </p:sp>
+      <p:sp>
+        <p:nvSpPr>
+          <p:cNvPr id="6" name="TextBox 5"/>
+          <p:cNvSpPr txBox="1"/>
+          <p:nvPr/>
+        </p:nvSpPr>
+        <p:spPr>
+          <a:xfrm>
+            <a:off x="10241280" y="320040"/>
+            <a:ext cx="1371600" cy="457200"/>
+          </a:xfrm>
+          <a:prstGeom prst="rect">
+            <a:avLst/>
+          </a:prstGeom>
+          <a:noFill/>
+        </p:spPr>
+        <p:txBody>
+          <a:bodyPr wrap="none">
+            <a:spAutoFit/>
+          </a:bodyPr>
+          <a:lstStyle/>
+          <a:p>
+            <a:pPr algn="r">
+              <a:defRPr sz="1600" b="1">
+                <a:solidFill>
+                  <a:srgbClr val="F59E0B"/>
+                </a:solidFill>
+              </a:defRPr>
+            </a:pPr>
+            <a:r>
+              <a:t>09 / 10</a:t>
+            </a:r>
+          </a:p>
+        </p:txBody>
+      </p:sp>
+      <p:sp>
+        <p:nvSpPr>
+          <p:cNvPr id="7" name="TextBox 6"/>
+          <p:cNvSpPr txBox="1"/>
+          <p:nvPr/>
+        </p:nvSpPr>
+        <p:spPr>
+          <a:xfrm>
+            <a:off x="731520" y="1371600"/>
+            <a:ext cx="5486400" cy="4937760"/>
+          </a:xfrm>
+          <a:prstGeom prst="rect">
+            <a:avLst/>
+          </a:prstGeom>
+          <a:noFill/>
+        </p:spPr>
+        <p:txBody>
+          <a:bodyPr wrap="square">
+            <a:spAutoFit/>
+          </a:bodyPr>
+          <a:lstStyle/>
+          <a:p>
+            <a:pPr>
+              <a:defRPr sz="1900" b="1">
+                <a:solidFill>
+                  <a:srgbClr val="1B4332"/>
+                </a:solidFill>
+              </a:defRPr>
+            </a:pPr>
+            <a:r>
+              <a:t>Impact on Campus Community:</a:t>
+            </a:r>
+          </a:p>
+          <a:p>
+            <a:pPr>
+              <a:spcBef>
+                <a:spcPts val="800"/>
+              </a:spcBef>
+            </a:pPr>
+            <a:r>
+              <a:rPr b="1" sz="1300">
+                <a:solidFill>
+                  <a:srgbClr val="1C2826"/>
+                </a:solidFill>
+              </a:rPr>
+              <a:t>• Convenient Item Access: </a:t>
+            </a:r>
+            <a:r>
+              <a:rPr sz="1200">
+                <a:solidFill>
+                  <a:srgbClr val="4B5D56"/>
+                </a:solidFill>
+              </a:rPr>
+              <a:t>Makes essential study tools and lab gear quick and easy to locate right when needed.</a:t>
+            </a:r>
+          </a:p>
+          <a:p>
+            <a:pPr>
+              <a:spcBef>
+                <a:spcPts val="800"/>
+              </a:spcBef>
+            </a:pPr>
+            <a:r>
+              <a:rPr b="1" sz="1300">
+                <a:solidFill>
+                  <a:srgbClr val="1C2826"/>
+                </a:solidFill>
+              </a:rPr>
+              <a:t>• Affordable Reuse: </a:t>
+            </a:r>
+            <a:r>
+              <a:rPr sz="1200">
+                <a:solidFill>
+                  <a:srgbClr val="4B5D56"/>
+                </a:solidFill>
+              </a:rPr>
+              <a:t>Reduces unnecessary purchases and promotes sustainable sharing among students.</a:t>
+            </a:r>
+          </a:p>
+          <a:p>
+            <a:pPr>
+              <a:spcBef>
+                <a:spcPts val="800"/>
+              </a:spcBef>
+            </a:pPr>
+            <a:r>
+              <a:rPr b="1" sz="1300">
+                <a:solidFill>
+                  <a:srgbClr val="1C2826"/>
+                </a:solidFill>
+              </a:rPr>
+              <a:t>• Earnings for Lenders: </a:t>
+            </a:r>
+            <a:r>
+              <a:rPr sz="1200">
+                <a:solidFill>
+                  <a:srgbClr val="4B5D56"/>
+                </a:solidFill>
+              </a:rPr>
+              <a:t>Helps students and clubs earn pocket money from equipment they already own.</a:t>
+            </a:r>
+          </a:p>
+          <a:p>
+            <a:pPr>
+              <a:spcBef>
+                <a:spcPts val="800"/>
+              </a:spcBef>
+            </a:pPr>
+            <a:r>
+              <a:rPr b="1" sz="1300">
+                <a:solidFill>
+                  <a:srgbClr val="1C2826"/>
+                </a:solidFill>
+              </a:rPr>
+              <a:t>• Future: Real UPI Payments: </a:t>
+            </a:r>
+            <a:r>
+              <a:rPr sz="1200">
+                <a:solidFill>
+                  <a:srgbClr val="4B5D56"/>
+                </a:solidFill>
+              </a:rPr>
+              <a:t>Integration with live college payment gateways (Google Pay, PhonePe, Paytm).</a:t>
+            </a:r>
+          </a:p>
+          <a:p>
+            <a:pPr>
+              <a:spcBef>
+                <a:spcPts val="800"/>
+              </a:spcBef>
+            </a:pPr>
+            <a:r>
+              <a:rPr b="1" sz="1300">
+                <a:solidFill>
+                  <a:srgbClr val="1C2826"/>
+                </a:solidFill>
+              </a:rPr>
+              <a:t>• Future: Student ID Verification: </a:t>
+            </a:r>
+            <a:r>
+              <a:rPr sz="1200">
+                <a:solidFill>
+                  <a:srgbClr val="4B5D56"/>
+                </a:solidFill>
+              </a:rPr>
+              <a:t>Campus roll number authentication and digital college ID verification.</a:t>
+            </a:r>
+          </a:p>
+          <a:p>
+            <a:pPr>
+              <a:spcBef>
+                <a:spcPts val="800"/>
+              </a:spcBef>
+            </a:pPr>
+            <a:r>
+              <a:rPr b="1" sz="1300">
+                <a:solidFill>
+                  <a:srgbClr val="1C2826"/>
+                </a:solidFill>
+              </a:rPr>
+              <a:t>• Future: Smart Pickup Lockers: </a:t>
+            </a:r>
+            <a:r>
+              <a:rPr sz="1200">
+                <a:solidFill>
+                  <a:srgbClr val="4B5D56"/>
+                </a:solidFill>
+              </a:rPr>
+              <a:t>QR-code enabled pickup lockers at central library and hostel entrances.</a:t>
+            </a:r>
+          </a:p>
+        </p:txBody>
+      </p:sp>
+      <p:pic>
+        <p:nvPicPr>
+          <p:cNvPr id="8" name="Picture 7" descr="slide9_scope.png"/>
+          <p:cNvPicPr>
+            <a:picLocks noChangeAspect="1"/>
+          </p:cNvPicPr>
+          <p:nvPr/>
+        </p:nvPicPr>
+        <p:blipFill>
+          <a:blip r:embed="rId2"/>
+          <a:stretch>
+            <a:fillRect/>
+          </a:stretch>
+        </p:blipFill>
+        <p:spPr>
+          <a:xfrm>
+            <a:off x="6492240" y="1371600"/>
+            <a:ext cx="5029200" cy="4846320"/>
           </a:xfrm>
           <a:prstGeom prst="rect">
             <a:avLst/>

</xml_diff>